<commit_message>
Remove slide subtitles from Command Pattern PPT
</commit_message>
<xml_diff>
--- a/강의자료/유니티 프로그래밍 패턴 2차시 - Command Pattern.pptx
+++ b/강의자료/유니티 프로그래밍 패턴 2차시 - Command Pattern.pptx
@@ -4480,54 +4480,13 @@
       </p:sp>
       <p:sp>
         <p:nvSpPr>
-          <p:cNvPr id="6" name="Text 4"/>
-          <p:cNvSpPr/>
-          <p:nvPr/>
-        </p:nvSpPr>
-        <p:spPr>
-          <a:xfrm>
-            <a:off x="841248" y="1956816"/>
-            <a:ext cx="7178040" cy="310896"/>
-          </a:xfrm>
-          <a:prstGeom prst="rect">
-            <a:avLst/>
-          </a:prstGeom>
-          <a:noFill/>
-          <a:ln/>
-        </p:spPr>
-        <p:txBody>
-          <a:bodyPr wrap="square" lIns="254" tIns="254" rIns="254" bIns="254" rtlCol="0" anchor="t">
-            <a:normAutofit/>
-          </a:bodyPr>
-          <a:lstStyle/>
-          <a:p>
-            <a:pPr indent="0" marL="0">
-              <a:buNone/>
-            </a:pPr>
-            <a:r>
-              <a:rPr lang="en-US" sz="1700" dirty="0">
-                <a:solidFill>
-                  <a:srgbClr val="D6DEE8"/>
-                </a:solidFill>
-                <a:latin typeface="Malgun Gothic" pitchFamily="34" charset="0"/>
-                <a:ea typeface="Malgun Gothic" pitchFamily="34" charset="-122"/>
-                <a:cs typeface="Malgun Gothic" pitchFamily="34" charset="-120"/>
-              </a:rPr>
-              <a:t>함수 호출을 객체로 만들면 입력, AI, Undo, Replay가 분리된다</a:t>
-            </a:r>
-            <a:endParaRPr lang="en-US" sz="1700" dirty="0"/>
-          </a:p>
-        </p:txBody>
-      </p:sp>
-      <p:sp>
-        <p:nvSpPr>
-          <p:cNvPr id="7" name="Shape 5"/>
-          <p:cNvSpPr/>
-          <p:nvPr/>
-        </p:nvSpPr>
-        <p:spPr>
-          <a:xfrm>
-            <a:off x="822960" y="2926080"/>
+          <p:cNvPr id="6" name="Shape 4"/>
+          <p:cNvSpPr/>
+          <p:nvPr/>
+        </p:nvSpPr>
+        <p:spPr>
+          <a:xfrm>
+            <a:off x="822960" y="2487168"/>
             <a:ext cx="1659636" cy="658368"/>
           </a:xfrm>
           <a:prstGeom prst="roundRect">
@@ -4548,13 +4507,13 @@
       </p:sp>
       <p:sp>
         <p:nvSpPr>
-          <p:cNvPr id="8" name="Text 6"/>
-          <p:cNvSpPr/>
-          <p:nvPr/>
-        </p:nvSpPr>
-        <p:spPr>
-          <a:xfrm>
-            <a:off x="896112" y="3127248"/>
+          <p:cNvPr id="7" name="Text 5"/>
+          <p:cNvSpPr/>
+          <p:nvPr/>
+        </p:nvSpPr>
+        <p:spPr>
+          <a:xfrm>
+            <a:off x="896112" y="2688336"/>
             <a:ext cx="1513332" cy="219456"/>
           </a:xfrm>
           <a:prstGeom prst="rect">
@@ -4589,13 +4548,13 @@
       </p:sp>
       <p:sp>
         <p:nvSpPr>
-          <p:cNvPr id="9" name="Text 7"/>
-          <p:cNvSpPr/>
-          <p:nvPr/>
-        </p:nvSpPr>
-        <p:spPr>
-          <a:xfrm>
-            <a:off x="2510028" y="3136392"/>
+          <p:cNvPr id="8" name="Text 6"/>
+          <p:cNvSpPr/>
+          <p:nvPr/>
+        </p:nvSpPr>
+        <p:spPr>
+          <a:xfrm>
+            <a:off x="2510028" y="2697480"/>
             <a:ext cx="109728" cy="182880"/>
           </a:xfrm>
           <a:prstGeom prst="rect">
@@ -4625,13 +4584,13 @@
       </p:sp>
       <p:sp>
         <p:nvSpPr>
-          <p:cNvPr id="10" name="Shape 8"/>
-          <p:cNvSpPr/>
-          <p:nvPr/>
-        </p:nvSpPr>
-        <p:spPr>
-          <a:xfrm>
-            <a:off x="2647188" y="2926080"/>
+          <p:cNvPr id="9" name="Shape 7"/>
+          <p:cNvSpPr/>
+          <p:nvPr/>
+        </p:nvSpPr>
+        <p:spPr>
+          <a:xfrm>
+            <a:off x="2647188" y="2487168"/>
             <a:ext cx="1659636" cy="658368"/>
           </a:xfrm>
           <a:prstGeom prst="roundRect">
@@ -4652,13 +4611,13 @@
       </p:sp>
       <p:sp>
         <p:nvSpPr>
-          <p:cNvPr id="11" name="Text 9"/>
-          <p:cNvSpPr/>
-          <p:nvPr/>
-        </p:nvSpPr>
-        <p:spPr>
-          <a:xfrm>
-            <a:off x="2720340" y="3127248"/>
+          <p:cNvPr id="10" name="Text 8"/>
+          <p:cNvSpPr/>
+          <p:nvPr/>
+        </p:nvSpPr>
+        <p:spPr>
+          <a:xfrm>
+            <a:off x="2720340" y="2688336"/>
             <a:ext cx="1513332" cy="219456"/>
           </a:xfrm>
           <a:prstGeom prst="rect">
@@ -4693,13 +4652,13 @@
       </p:sp>
       <p:sp>
         <p:nvSpPr>
-          <p:cNvPr id="12" name="Text 10"/>
-          <p:cNvSpPr/>
-          <p:nvPr/>
-        </p:nvSpPr>
-        <p:spPr>
-          <a:xfrm>
-            <a:off x="4334256" y="3136392"/>
+          <p:cNvPr id="11" name="Text 9"/>
+          <p:cNvSpPr/>
+          <p:nvPr/>
+        </p:nvSpPr>
+        <p:spPr>
+          <a:xfrm>
+            <a:off x="4334256" y="2697480"/>
             <a:ext cx="109728" cy="182880"/>
           </a:xfrm>
           <a:prstGeom prst="rect">
@@ -4729,13 +4688,13 @@
       </p:sp>
       <p:sp>
         <p:nvSpPr>
-          <p:cNvPr id="13" name="Shape 11"/>
-          <p:cNvSpPr/>
-          <p:nvPr/>
-        </p:nvSpPr>
-        <p:spPr>
-          <a:xfrm>
-            <a:off x="4471416" y="2926080"/>
+          <p:cNvPr id="12" name="Shape 10"/>
+          <p:cNvSpPr/>
+          <p:nvPr/>
+        </p:nvSpPr>
+        <p:spPr>
+          <a:xfrm>
+            <a:off x="4471416" y="2487168"/>
             <a:ext cx="1659636" cy="658368"/>
           </a:xfrm>
           <a:prstGeom prst="roundRect">
@@ -4756,13 +4715,13 @@
       </p:sp>
       <p:sp>
         <p:nvSpPr>
-          <p:cNvPr id="14" name="Text 12"/>
-          <p:cNvSpPr/>
-          <p:nvPr/>
-        </p:nvSpPr>
-        <p:spPr>
-          <a:xfrm>
-            <a:off x="4544568" y="3127248"/>
+          <p:cNvPr id="13" name="Text 11"/>
+          <p:cNvSpPr/>
+          <p:nvPr/>
+        </p:nvSpPr>
+        <p:spPr>
+          <a:xfrm>
+            <a:off x="4544568" y="2688336"/>
             <a:ext cx="1513332" cy="219456"/>
           </a:xfrm>
           <a:prstGeom prst="rect">
@@ -4797,13 +4756,13 @@
       </p:sp>
       <p:sp>
         <p:nvSpPr>
-          <p:cNvPr id="15" name="Text 13"/>
-          <p:cNvSpPr/>
-          <p:nvPr/>
-        </p:nvSpPr>
-        <p:spPr>
-          <a:xfrm>
-            <a:off x="6158484" y="3136392"/>
+          <p:cNvPr id="14" name="Text 12"/>
+          <p:cNvSpPr/>
+          <p:nvPr/>
+        </p:nvSpPr>
+        <p:spPr>
+          <a:xfrm>
+            <a:off x="6158484" y="2697480"/>
             <a:ext cx="109728" cy="182880"/>
           </a:xfrm>
           <a:prstGeom prst="rect">
@@ -4833,13 +4792,13 @@
       </p:sp>
       <p:sp>
         <p:nvSpPr>
-          <p:cNvPr id="16" name="Shape 14"/>
-          <p:cNvSpPr/>
-          <p:nvPr/>
-        </p:nvSpPr>
-        <p:spPr>
-          <a:xfrm>
-            <a:off x="6295644" y="2926080"/>
+          <p:cNvPr id="15" name="Shape 13"/>
+          <p:cNvSpPr/>
+          <p:nvPr/>
+        </p:nvSpPr>
+        <p:spPr>
+          <a:xfrm>
+            <a:off x="6295644" y="2487168"/>
             <a:ext cx="1659636" cy="658368"/>
           </a:xfrm>
           <a:prstGeom prst="roundRect">
@@ -4860,13 +4819,13 @@
       </p:sp>
       <p:sp>
         <p:nvSpPr>
-          <p:cNvPr id="17" name="Text 15"/>
-          <p:cNvSpPr/>
-          <p:nvPr/>
-        </p:nvSpPr>
-        <p:spPr>
-          <a:xfrm>
-            <a:off x="6368796" y="3127248"/>
+          <p:cNvPr id="16" name="Text 14"/>
+          <p:cNvSpPr/>
+          <p:nvPr/>
+        </p:nvSpPr>
+        <p:spPr>
+          <a:xfrm>
+            <a:off x="6368796" y="2688336"/>
             <a:ext cx="1513332" cy="219456"/>
           </a:xfrm>
           <a:prstGeom prst="rect">
@@ -4901,7 +4860,7 @@
       </p:sp>
       <p:sp>
         <p:nvSpPr>
-          <p:cNvPr id="18" name="Text 16"/>
+          <p:cNvPr id="17" name="Text 15"/>
           <p:cNvSpPr/>
           <p:nvPr/>
         </p:nvSpPr>
@@ -5149,17 +5108,17 @@
         </p:nvSpPr>
         <p:spPr>
           <a:xfrm>
-            <a:off x="612648" y="822960"/>
-            <a:ext cx="7498080" cy="228600"/>
-          </a:xfrm>
-          <a:prstGeom prst="rect">
-            <a:avLst/>
-          </a:prstGeom>
-          <a:noFill/>
-          <a:ln/>
-        </p:spPr>
-        <p:txBody>
-          <a:bodyPr wrap="square" lIns="0" tIns="0" rIns="0" bIns="0" rtlCol="0" anchor="ctr">
+            <a:off x="713232" y="1115568"/>
+            <a:ext cx="7498080" cy="274320"/>
+          </a:xfrm>
+          <a:prstGeom prst="rect">
+            <a:avLst/>
+          </a:prstGeom>
+          <a:noFill/>
+          <a:ln/>
+        </p:spPr>
+        <p:txBody>
+          <a:bodyPr wrap="square" lIns="254" tIns="254" rIns="254" bIns="254" rtlCol="0" anchor="t">
             <a:normAutofit/>
           </a:bodyPr>
           <a:lstStyle/>
@@ -5168,55 +5127,14 @@
               <a:buNone/>
             </a:pPr>
             <a:r>
-              <a:rPr lang="en-US" sz="1150" dirty="0">
-                <a:solidFill>
-                  <a:srgbClr val="606B78"/>
+              <a:rPr lang="en-US" sz="1550" b="1" dirty="0">
+                <a:solidFill>
+                  <a:srgbClr val="0F766E"/>
                 </a:solidFill>
                 <a:latin typeface="Malgun Gothic" pitchFamily="34" charset="0"/>
                 <a:ea typeface="Malgun Gothic" pitchFamily="34" charset="-122"/>
                 <a:cs typeface="Malgun Gothic" pitchFamily="34" charset="-120"/>
               </a:rPr>
-              <a:t>null 체크 대신 빈 행동을 객체로 표현한다</a:t>
-            </a:r>
-            <a:endParaRPr lang="en-US" sz="1150" dirty="0"/>
-          </a:p>
-        </p:txBody>
-      </p:sp>
-      <p:sp>
-        <p:nvSpPr>
-          <p:cNvPr id="8" name="Text 6"/>
-          <p:cNvSpPr/>
-          <p:nvPr/>
-        </p:nvSpPr>
-        <p:spPr>
-          <a:xfrm>
-            <a:off x="713232" y="1115568"/>
-            <a:ext cx="7498080" cy="274320"/>
-          </a:xfrm>
-          <a:prstGeom prst="rect">
-            <a:avLst/>
-          </a:prstGeom>
-          <a:noFill/>
-          <a:ln/>
-        </p:spPr>
-        <p:txBody>
-          <a:bodyPr wrap="square" lIns="254" tIns="254" rIns="254" bIns="254" rtlCol="0" anchor="t">
-            <a:normAutofit/>
-          </a:bodyPr>
-          <a:lstStyle/>
-          <a:p>
-            <a:pPr indent="0" marL="0">
-              <a:buNone/>
-            </a:pPr>
-            <a:r>
-              <a:rPr lang="en-US" sz="1550" b="1" dirty="0">
-                <a:solidFill>
-                  <a:srgbClr val="0F766E"/>
-                </a:solidFill>
-                <a:latin typeface="Malgun Gothic" pitchFamily="34" charset="0"/>
-                <a:ea typeface="Malgun Gothic" pitchFamily="34" charset="-122"/>
-                <a:cs typeface="Malgun Gothic" pitchFamily="34" charset="-120"/>
-              </a:rPr>
               <a:t>버튼은 있지만 아직 기능이 없을 수 있다.</a:t>
             </a:r>
             <a:endParaRPr lang="en-US" sz="1550" dirty="0"/>
@@ -5225,7 +5143,7 @@
       </p:sp>
       <p:sp>
         <p:nvSpPr>
-          <p:cNvPr id="9" name="Shape 7"/>
+          <p:cNvPr id="8" name="Shape 6"/>
           <p:cNvSpPr/>
           <p:nvPr/>
         </p:nvSpPr>
@@ -5254,7 +5172,7 @@
       </p:sp>
       <p:sp>
         <p:nvSpPr>
-          <p:cNvPr id="10" name="Text 8"/>
+          <p:cNvPr id="9" name="Text 7"/>
           <p:cNvSpPr/>
           <p:nvPr/>
         </p:nvSpPr>
@@ -5627,17 +5545,17 @@
         </p:nvSpPr>
         <p:spPr>
           <a:xfrm>
-            <a:off x="612648" y="822960"/>
-            <a:ext cx="7498080" cy="228600"/>
-          </a:xfrm>
-          <a:prstGeom prst="rect">
-            <a:avLst/>
-          </a:prstGeom>
-          <a:noFill/>
-          <a:ln/>
-        </p:spPr>
-        <p:txBody>
-          <a:bodyPr wrap="square" lIns="0" tIns="0" rIns="0" bIns="0" rtlCol="0" anchor="ctr">
+            <a:off x="749808" y="1335024"/>
+            <a:ext cx="7498080" cy="512064"/>
+          </a:xfrm>
+          <a:prstGeom prst="rect">
+            <a:avLst/>
+          </a:prstGeom>
+          <a:noFill/>
+          <a:ln/>
+        </p:spPr>
+        <p:txBody>
+          <a:bodyPr wrap="square" lIns="254" tIns="254" rIns="254" bIns="254" rtlCol="0" anchor="t">
             <a:normAutofit/>
           </a:bodyPr>
           <a:lstStyle/>
@@ -5646,55 +5564,14 @@
               <a:buNone/>
             </a:pPr>
             <a:r>
-              <a:rPr lang="en-US" sz="1150" dirty="0">
-                <a:solidFill>
-                  <a:srgbClr val="606B78"/>
+              <a:rPr lang="en-US" sz="1840" b="1" dirty="0">
+                <a:solidFill>
+                  <a:srgbClr val="17212B"/>
                 </a:solidFill>
                 <a:latin typeface="Malgun Gothic" pitchFamily="34" charset="0"/>
                 <a:ea typeface="Malgun Gothic" pitchFamily="34" charset="-122"/>
                 <a:cs typeface="Malgun Gothic" pitchFamily="34" charset="-120"/>
               </a:rPr>
-              <a:t>직접 호출에서 객체 교체로 바뀐다</a:t>
-            </a:r>
-            <a:endParaRPr lang="en-US" sz="1150" dirty="0"/>
-          </a:p>
-        </p:txBody>
-      </p:sp>
-      <p:sp>
-        <p:nvSpPr>
-          <p:cNvPr id="8" name="Text 6"/>
-          <p:cNvSpPr/>
-          <p:nvPr/>
-        </p:nvSpPr>
-        <p:spPr>
-          <a:xfrm>
-            <a:off x="749808" y="1335024"/>
-            <a:ext cx="7498080" cy="512064"/>
-          </a:xfrm>
-          <a:prstGeom prst="rect">
-            <a:avLst/>
-          </a:prstGeom>
-          <a:noFill/>
-          <a:ln/>
-        </p:spPr>
-        <p:txBody>
-          <a:bodyPr wrap="square" lIns="254" tIns="254" rIns="254" bIns="254" rtlCol="0" anchor="t">
-            <a:normAutofit/>
-          </a:bodyPr>
-          <a:lstStyle/>
-          <a:p>
-            <a:pPr indent="0" marL="0">
-              <a:buNone/>
-            </a:pPr>
-            <a:r>
-              <a:rPr lang="en-US" sz="1840" b="1" dirty="0">
-                <a:solidFill>
-                  <a:srgbClr val="17212B"/>
-                </a:solidFill>
-                <a:latin typeface="Malgun Gothic" pitchFamily="34" charset="0"/>
-                <a:ea typeface="Malgun Gothic" pitchFamily="34" charset="-122"/>
-                <a:cs typeface="Malgun Gothic" pitchFamily="34" charset="-120"/>
-              </a:rPr>
               <a:t>함수 호출을 객체로 만들면 버튼 설정을 런타임에 바꿀 수 있다.</a:t>
             </a:r>
             <a:endParaRPr lang="en-US" sz="1840" dirty="0"/>
@@ -5703,7 +5580,7 @@
       </p:sp>
       <p:sp>
         <p:nvSpPr>
-          <p:cNvPr id="9" name="Shape 7"/>
+          <p:cNvPr id="8" name="Shape 6"/>
           <p:cNvSpPr/>
           <p:nvPr/>
         </p:nvSpPr>
@@ -5730,7 +5607,7 @@
       </p:sp>
       <p:sp>
         <p:nvSpPr>
-          <p:cNvPr id="10" name="Text 8"/>
+          <p:cNvPr id="9" name="Text 7"/>
           <p:cNvSpPr/>
           <p:nvPr/>
         </p:nvSpPr>
@@ -5771,7 +5648,7 @@
       </p:sp>
       <p:sp>
         <p:nvSpPr>
-          <p:cNvPr id="11" name="Text 9"/>
+          <p:cNvPr id="10" name="Text 8"/>
           <p:cNvSpPr/>
           <p:nvPr/>
         </p:nvSpPr>
@@ -5807,7 +5684,7 @@
       </p:sp>
       <p:sp>
         <p:nvSpPr>
-          <p:cNvPr id="12" name="Shape 10"/>
+          <p:cNvPr id="11" name="Shape 9"/>
           <p:cNvSpPr/>
           <p:nvPr/>
         </p:nvSpPr>
@@ -5834,7 +5711,7 @@
       </p:sp>
       <p:sp>
         <p:nvSpPr>
-          <p:cNvPr id="13" name="Text 11"/>
+          <p:cNvPr id="12" name="Text 10"/>
           <p:cNvSpPr/>
           <p:nvPr/>
         </p:nvSpPr>
@@ -5875,7 +5752,7 @@
       </p:sp>
       <p:sp>
         <p:nvSpPr>
-          <p:cNvPr id="14" name="Text 12"/>
+          <p:cNvPr id="13" name="Text 11"/>
           <p:cNvSpPr/>
           <p:nvPr/>
         </p:nvSpPr>
@@ -5911,7 +5788,7 @@
       </p:sp>
       <p:sp>
         <p:nvSpPr>
-          <p:cNvPr id="15" name="Shape 13"/>
+          <p:cNvPr id="14" name="Shape 12"/>
           <p:cNvSpPr/>
           <p:nvPr/>
         </p:nvSpPr>
@@ -5938,7 +5815,7 @@
       </p:sp>
       <p:sp>
         <p:nvSpPr>
-          <p:cNvPr id="16" name="Text 14"/>
+          <p:cNvPr id="15" name="Text 13"/>
           <p:cNvSpPr/>
           <p:nvPr/>
         </p:nvSpPr>
@@ -5979,7 +5856,7 @@
       </p:sp>
       <p:sp>
         <p:nvSpPr>
-          <p:cNvPr id="17" name="Text 15"/>
+          <p:cNvPr id="16" name="Text 14"/>
           <p:cNvSpPr/>
           <p:nvPr/>
         </p:nvSpPr>
@@ -6015,7 +5892,7 @@
       </p:sp>
       <p:sp>
         <p:nvSpPr>
-          <p:cNvPr id="18" name="Shape 16"/>
+          <p:cNvPr id="17" name="Shape 15"/>
           <p:cNvSpPr/>
           <p:nvPr/>
         </p:nvSpPr>
@@ -6042,7 +5919,7 @@
       </p:sp>
       <p:sp>
         <p:nvSpPr>
-          <p:cNvPr id="19" name="Text 17"/>
+          <p:cNvPr id="18" name="Text 16"/>
           <p:cNvSpPr/>
           <p:nvPr/>
         </p:nvSpPr>
@@ -6083,7 +5960,7 @@
       </p:sp>
       <p:sp>
         <p:nvSpPr>
-          <p:cNvPr id="20" name="Shape 18"/>
+          <p:cNvPr id="19" name="Shape 17"/>
           <p:cNvSpPr/>
           <p:nvPr/>
         </p:nvSpPr>
@@ -6108,7 +5985,7 @@
       </p:sp>
       <p:sp>
         <p:nvSpPr>
-          <p:cNvPr id="21" name="Text 19"/>
+          <p:cNvPr id="20" name="Text 18"/>
           <p:cNvSpPr/>
           <p:nvPr/>
         </p:nvSpPr>
@@ -6149,7 +6026,7 @@
       </p:sp>
       <p:sp>
         <p:nvSpPr>
-          <p:cNvPr id="22" name="Shape 20"/>
+          <p:cNvPr id="21" name="Shape 19"/>
           <p:cNvSpPr/>
           <p:nvPr/>
         </p:nvSpPr>
@@ -6174,7 +6051,7 @@
       </p:sp>
       <p:sp>
         <p:nvSpPr>
-          <p:cNvPr id="23" name="Text 21"/>
+          <p:cNvPr id="22" name="Text 20"/>
           <p:cNvSpPr/>
           <p:nvPr/>
         </p:nvSpPr>
@@ -6422,17 +6299,17 @@
         </p:nvSpPr>
         <p:spPr>
           <a:xfrm>
-            <a:off x="612648" y="822960"/>
-            <a:ext cx="7498080" cy="228600"/>
-          </a:xfrm>
-          <a:prstGeom prst="rect">
-            <a:avLst/>
-          </a:prstGeom>
-          <a:noFill/>
-          <a:ln/>
-        </p:spPr>
-        <p:txBody>
-          <a:bodyPr wrap="square" lIns="0" tIns="0" rIns="0" bIns="0" rtlCol="0" anchor="ctr">
+            <a:off x="804672" y="1371600"/>
+            <a:ext cx="3474720" cy="320040"/>
+          </a:xfrm>
+          <a:prstGeom prst="rect">
+            <a:avLst/>
+          </a:prstGeom>
+          <a:noFill/>
+          <a:ln/>
+        </p:spPr>
+        <p:txBody>
+          <a:bodyPr wrap="square" lIns="254" tIns="254" rIns="254" bIns="254" rtlCol="0" anchor="t">
             <a:normAutofit/>
           </a:bodyPr>
           <a:lstStyle/>
@@ -6441,55 +6318,14 @@
               <a:buNone/>
             </a:pPr>
             <a:r>
-              <a:rPr lang="en-US" sz="1150" dirty="0">
-                <a:solidFill>
-                  <a:srgbClr val="606B78"/>
+              <a:rPr lang="en-US" sz="1950" b="1" dirty="0">
+                <a:solidFill>
+                  <a:srgbClr val="E45745"/>
                 </a:solidFill>
                 <a:latin typeface="Malgun Gothic" pitchFamily="34" charset="0"/>
                 <a:ea typeface="Malgun Gothic" pitchFamily="34" charset="-122"/>
                 <a:cs typeface="Malgun Gothic" pitchFamily="34" charset="-120"/>
               </a:rPr>
-              <a:t>Command가 플레이어에게 너무 묶여 있다</a:t>
-            </a:r>
-            <a:endParaRPr lang="en-US" sz="1150" dirty="0"/>
-          </a:p>
-        </p:txBody>
-      </p:sp>
-      <p:sp>
-        <p:nvSpPr>
-          <p:cNvPr id="8" name="Text 6"/>
-          <p:cNvSpPr/>
-          <p:nvPr/>
-        </p:nvSpPr>
-        <p:spPr>
-          <a:xfrm>
-            <a:off x="804672" y="1371600"/>
-            <a:ext cx="3474720" cy="320040"/>
-          </a:xfrm>
-          <a:prstGeom prst="rect">
-            <a:avLst/>
-          </a:prstGeom>
-          <a:noFill/>
-          <a:ln/>
-        </p:spPr>
-        <p:txBody>
-          <a:bodyPr wrap="square" lIns="254" tIns="254" rIns="254" bIns="254" rtlCol="0" anchor="t">
-            <a:normAutofit/>
-          </a:bodyPr>
-          <a:lstStyle/>
-          <a:p>
-            <a:pPr indent="0" marL="0">
-              <a:buNone/>
-            </a:pPr>
-            <a:r>
-              <a:rPr lang="en-US" sz="1950" b="1" dirty="0">
-                <a:solidFill>
-                  <a:srgbClr val="E45745"/>
-                </a:solidFill>
-                <a:latin typeface="Malgun Gothic" pitchFamily="34" charset="0"/>
-                <a:ea typeface="Malgun Gothic" pitchFamily="34" charset="-122"/>
-                <a:cs typeface="Malgun Gothic" pitchFamily="34" charset="-120"/>
-              </a:rPr>
               <a:t>문제</a:t>
             </a:r>
             <a:endParaRPr lang="en-US" sz="1950" dirty="0"/>
@@ -6498,7 +6334,7 @@
       </p:sp>
       <p:sp>
         <p:nvSpPr>
-          <p:cNvPr id="9" name="Shape 7"/>
+          <p:cNvPr id="8" name="Shape 6"/>
           <p:cNvSpPr/>
           <p:nvPr/>
         </p:nvSpPr>
@@ -6523,7 +6359,7 @@
       </p:sp>
       <p:sp>
         <p:nvSpPr>
-          <p:cNvPr id="10" name="Text 8"/>
+          <p:cNvPr id="9" name="Text 7"/>
           <p:cNvSpPr/>
           <p:nvPr/>
         </p:nvSpPr>
@@ -6564,7 +6400,7 @@
       </p:sp>
       <p:sp>
         <p:nvSpPr>
-          <p:cNvPr id="11" name="Shape 9"/>
+          <p:cNvPr id="10" name="Shape 8"/>
           <p:cNvSpPr/>
           <p:nvPr/>
         </p:nvSpPr>
@@ -6589,7 +6425,7 @@
       </p:sp>
       <p:sp>
         <p:nvSpPr>
-          <p:cNvPr id="12" name="Text 10"/>
+          <p:cNvPr id="11" name="Text 9"/>
           <p:cNvSpPr/>
           <p:nvPr/>
         </p:nvSpPr>
@@ -6630,7 +6466,7 @@
       </p:sp>
       <p:sp>
         <p:nvSpPr>
-          <p:cNvPr id="13" name="Shape 11"/>
+          <p:cNvPr id="12" name="Shape 10"/>
           <p:cNvSpPr/>
           <p:nvPr/>
         </p:nvSpPr>
@@ -6655,7 +6491,7 @@
       </p:sp>
       <p:sp>
         <p:nvSpPr>
-          <p:cNvPr id="14" name="Text 12"/>
+          <p:cNvPr id="13" name="Text 11"/>
           <p:cNvSpPr/>
           <p:nvPr/>
         </p:nvSpPr>
@@ -6696,7 +6532,7 @@
       </p:sp>
       <p:sp>
         <p:nvSpPr>
-          <p:cNvPr id="15" name="Text 13"/>
+          <p:cNvPr id="14" name="Text 12"/>
           <p:cNvSpPr/>
           <p:nvPr/>
         </p:nvSpPr>
@@ -6737,7 +6573,7 @@
       </p:sp>
       <p:sp>
         <p:nvSpPr>
-          <p:cNvPr id="16" name="Shape 14"/>
+          <p:cNvPr id="15" name="Shape 13"/>
           <p:cNvSpPr/>
           <p:nvPr/>
         </p:nvSpPr>
@@ -6762,7 +6598,7 @@
       </p:sp>
       <p:sp>
         <p:nvSpPr>
-          <p:cNvPr id="17" name="Text 15"/>
+          <p:cNvPr id="16" name="Text 14"/>
           <p:cNvSpPr/>
           <p:nvPr/>
         </p:nvSpPr>
@@ -6803,7 +6639,7 @@
       </p:sp>
       <p:sp>
         <p:nvSpPr>
-          <p:cNvPr id="18" name="Shape 16"/>
+          <p:cNvPr id="17" name="Shape 15"/>
           <p:cNvSpPr/>
           <p:nvPr/>
         </p:nvSpPr>
@@ -6828,7 +6664,7 @@
       </p:sp>
       <p:sp>
         <p:nvSpPr>
-          <p:cNvPr id="19" name="Text 17"/>
+          <p:cNvPr id="18" name="Text 16"/>
           <p:cNvSpPr/>
           <p:nvPr/>
         </p:nvSpPr>
@@ -6869,7 +6705,7 @@
       </p:sp>
       <p:sp>
         <p:nvSpPr>
-          <p:cNvPr id="20" name="Shape 18"/>
+          <p:cNvPr id="19" name="Shape 17"/>
           <p:cNvSpPr/>
           <p:nvPr/>
         </p:nvSpPr>
@@ -6894,7 +6730,7 @@
       </p:sp>
       <p:sp>
         <p:nvSpPr>
-          <p:cNvPr id="21" name="Text 19"/>
+          <p:cNvPr id="20" name="Text 18"/>
           <p:cNvSpPr/>
           <p:nvPr/>
         </p:nvSpPr>
@@ -7142,17 +6978,17 @@
         </p:nvSpPr>
         <p:spPr>
           <a:xfrm>
-            <a:off x="612648" y="822960"/>
-            <a:ext cx="7498080" cy="228600"/>
-          </a:xfrm>
-          <a:prstGeom prst="rect">
-            <a:avLst/>
-          </a:prstGeom>
-          <a:noFill/>
-          <a:ln/>
-        </p:spPr>
-        <p:txBody>
-          <a:bodyPr wrap="square" lIns="0" tIns="0" rIns="0" bIns="0" rtlCol="0" anchor="ctr">
+            <a:off x="713232" y="1115568"/>
+            <a:ext cx="7498080" cy="274320"/>
+          </a:xfrm>
+          <a:prstGeom prst="rect">
+            <a:avLst/>
+          </a:prstGeom>
+          <a:noFill/>
+          <a:ln/>
+        </p:spPr>
+        <p:txBody>
+          <a:bodyPr wrap="square" lIns="254" tIns="254" rIns="254" bIns="254" rtlCol="0" anchor="t">
             <a:normAutofit/>
           </a:bodyPr>
           <a:lstStyle/>
@@ -7161,55 +6997,14 @@
               <a:buNone/>
             </a:pPr>
             <a:r>
-              <a:rPr lang="en-US" sz="1150" dirty="0">
-                <a:solidFill>
-                  <a:srgbClr val="606B78"/>
+              <a:rPr lang="en-US" sz="1550" b="1" dirty="0">
+                <a:solidFill>
+                  <a:srgbClr val="0F766E"/>
                 </a:solidFill>
                 <a:latin typeface="Malgun Gothic" pitchFamily="34" charset="0"/>
                 <a:ea typeface="Malgun Gothic" pitchFamily="34" charset="-122"/>
                 <a:cs typeface="Malgun Gothic" pitchFamily="34" charset="-120"/>
               </a:rPr>
-              <a:t>명령은 행동을 알고, 대상은 외부에서 정한다</a:t>
-            </a:r>
-            <a:endParaRPr lang="en-US" sz="1150" dirty="0"/>
-          </a:p>
-        </p:txBody>
-      </p:sp>
-      <p:sp>
-        <p:nvSpPr>
-          <p:cNvPr id="8" name="Text 6"/>
-          <p:cNvSpPr/>
-          <p:nvPr/>
-        </p:nvSpPr>
-        <p:spPr>
-          <a:xfrm>
-            <a:off x="713232" y="1115568"/>
-            <a:ext cx="7498080" cy="274320"/>
-          </a:xfrm>
-          <a:prstGeom prst="rect">
-            <a:avLst/>
-          </a:prstGeom>
-          <a:noFill/>
-          <a:ln/>
-        </p:spPr>
-        <p:txBody>
-          <a:bodyPr wrap="square" lIns="254" tIns="254" rIns="254" bIns="254" rtlCol="0" anchor="t">
-            <a:normAutofit/>
-          </a:bodyPr>
-          <a:lstStyle/>
-          <a:p>
-            <a:pPr indent="0" marL="0">
-              <a:buNone/>
-            </a:pPr>
-            <a:r>
-              <a:rPr lang="en-US" sz="1550" b="1" dirty="0">
-                <a:solidFill>
-                  <a:srgbClr val="0F766E"/>
-                </a:solidFill>
-                <a:latin typeface="Malgun Gothic" pitchFamily="34" charset="0"/>
-                <a:ea typeface="Malgun Gothic" pitchFamily="34" charset="-122"/>
-                <a:cs typeface="Malgun Gothic" pitchFamily="34" charset="-120"/>
-              </a:rPr>
               <a:t>같은 명령을 플레이어, AI, 다른 유닛에게 쓸 수 있다.</a:t>
             </a:r>
             <a:endParaRPr lang="en-US" sz="1550" dirty="0"/>
@@ -7218,7 +7013,7 @@
       </p:sp>
       <p:sp>
         <p:nvSpPr>
-          <p:cNvPr id="9" name="Shape 7"/>
+          <p:cNvPr id="8" name="Shape 6"/>
           <p:cNvSpPr/>
           <p:nvPr/>
         </p:nvSpPr>
@@ -7247,7 +7042,7 @@
       </p:sp>
       <p:sp>
         <p:nvSpPr>
-          <p:cNvPr id="10" name="Text 8"/>
+          <p:cNvPr id="9" name="Text 7"/>
           <p:cNvSpPr/>
           <p:nvPr/>
         </p:nvSpPr>
@@ -7671,17 +7466,17 @@
         </p:nvSpPr>
         <p:spPr>
           <a:xfrm>
-            <a:off x="612648" y="822960"/>
-            <a:ext cx="7498080" cy="228600"/>
-          </a:xfrm>
-          <a:prstGeom prst="rect">
-            <a:avLst/>
-          </a:prstGeom>
-          <a:noFill/>
-          <a:ln/>
-        </p:spPr>
-        <p:txBody>
-          <a:bodyPr wrap="square" lIns="0" tIns="0" rIns="0" bIns="0" rtlCol="0" anchor="ctr">
+            <a:off x="713232" y="1115568"/>
+            <a:ext cx="7498080" cy="274320"/>
+          </a:xfrm>
+          <a:prstGeom prst="rect">
+            <a:avLst/>
+          </a:prstGeom>
+          <a:noFill/>
+          <a:ln/>
+        </p:spPr>
+        <p:txBody>
+          <a:bodyPr wrap="square" lIns="254" tIns="254" rIns="254" bIns="254" rtlCol="0" anchor="t">
             <a:normAutofit/>
           </a:bodyPr>
           <a:lstStyle/>
@@ -7690,55 +7485,14 @@
               <a:buNone/>
             </a:pPr>
             <a:r>
-              <a:rPr lang="en-US" sz="1150" dirty="0">
-                <a:solidFill>
-                  <a:srgbClr val="606B78"/>
+              <a:rPr lang="en-US" sz="1550" b="1" dirty="0">
+                <a:solidFill>
+                  <a:srgbClr val="0F766E"/>
                 </a:solidFill>
                 <a:latin typeface="Malgun Gothic" pitchFamily="34" charset="0"/>
                 <a:ea typeface="Malgun Gothic" pitchFamily="34" charset="-122"/>
                 <a:cs typeface="Malgun Gothic" pitchFamily="34" charset="-120"/>
               </a:rPr>
-              <a:t>실행 대상은 상위 시스템이 고른다</a:t>
-            </a:r>
-            <a:endParaRPr lang="en-US" sz="1150" dirty="0"/>
-          </a:p>
-        </p:txBody>
-      </p:sp>
-      <p:sp>
-        <p:nvSpPr>
-          <p:cNvPr id="8" name="Text 6"/>
-          <p:cNvSpPr/>
-          <p:nvPr/>
-        </p:nvSpPr>
-        <p:spPr>
-          <a:xfrm>
-            <a:off x="713232" y="1115568"/>
-            <a:ext cx="7498080" cy="274320"/>
-          </a:xfrm>
-          <a:prstGeom prst="rect">
-            <a:avLst/>
-          </a:prstGeom>
-          <a:noFill/>
-          <a:ln/>
-        </p:spPr>
-        <p:txBody>
-          <a:bodyPr wrap="square" lIns="254" tIns="254" rIns="254" bIns="254" rtlCol="0" anchor="t">
-            <a:normAutofit/>
-          </a:bodyPr>
-          <a:lstStyle/>
-          <a:p>
-            <a:pPr indent="0" marL="0">
-              <a:buNone/>
-            </a:pPr>
-            <a:r>
-              <a:rPr lang="en-US" sz="1550" b="1" dirty="0">
-                <a:solidFill>
-                  <a:srgbClr val="0F766E"/>
-                </a:solidFill>
-                <a:latin typeface="Malgun Gothic" pitchFamily="34" charset="0"/>
-                <a:ea typeface="Malgun Gothic" pitchFamily="34" charset="-122"/>
-                <a:cs typeface="Malgun Gothic" pitchFamily="34" charset="-120"/>
-              </a:rPr>
               <a:t>입력 핸들러는 번역만 담당한다.</a:t>
             </a:r>
             <a:endParaRPr lang="en-US" sz="1550" dirty="0"/>
@@ -7747,7 +7501,7 @@
       </p:sp>
       <p:sp>
         <p:nvSpPr>
-          <p:cNvPr id="9" name="Shape 7"/>
+          <p:cNvPr id="8" name="Shape 6"/>
           <p:cNvSpPr/>
           <p:nvPr/>
         </p:nvSpPr>
@@ -7776,7 +7530,7 @@
       </p:sp>
       <p:sp>
         <p:nvSpPr>
-          <p:cNvPr id="10" name="Text 8"/>
+          <p:cNvPr id="9" name="Text 7"/>
           <p:cNvSpPr/>
           <p:nvPr/>
         </p:nvSpPr>
@@ -8109,17 +7863,17 @@
         </p:nvSpPr>
         <p:spPr>
           <a:xfrm>
-            <a:off x="612648" y="822960"/>
-            <a:ext cx="7498080" cy="228600"/>
-          </a:xfrm>
-          <a:prstGeom prst="rect">
-            <a:avLst/>
-          </a:prstGeom>
-          <a:noFill/>
-          <a:ln/>
-        </p:spPr>
-        <p:txBody>
-          <a:bodyPr wrap="square" lIns="0" tIns="0" rIns="0" bIns="0" rtlCol="0" anchor="ctr">
+            <a:off x="713232" y="1115568"/>
+            <a:ext cx="7498080" cy="274320"/>
+          </a:xfrm>
+          <a:prstGeom prst="rect">
+            <a:avLst/>
+          </a:prstGeom>
+          <a:noFill/>
+          <a:ln/>
+        </p:spPr>
+        <p:txBody>
+          <a:bodyPr wrap="square" lIns="254" tIns="254" rIns="254" bIns="254" rtlCol="0" anchor="t">
             <a:normAutofit/>
           </a:bodyPr>
           <a:lstStyle/>
@@ -8128,55 +7882,14 @@
               <a:buNone/>
             </a:pPr>
             <a:r>
-              <a:rPr lang="en-US" sz="1150" dirty="0">
-                <a:solidFill>
-                  <a:srgbClr val="606B78"/>
+              <a:rPr lang="en-US" sz="1550" b="1" dirty="0">
+                <a:solidFill>
+                  <a:srgbClr val="0F766E"/>
                 </a:solidFill>
                 <a:latin typeface="Malgun Gothic" pitchFamily="34" charset="0"/>
                 <a:ea typeface="Malgun Gothic" pitchFamily="34" charset="-122"/>
                 <a:cs typeface="Malgun Gothic" pitchFamily="34" charset="-120"/>
               </a:rPr>
-              <a:t>현재 선택된 Actor에게 명령을 적용한다</a:t>
-            </a:r>
-            <a:endParaRPr lang="en-US" sz="1150" dirty="0"/>
-          </a:p>
-        </p:txBody>
-      </p:sp>
-      <p:sp>
-        <p:nvSpPr>
-          <p:cNvPr id="8" name="Text 6"/>
-          <p:cNvSpPr/>
-          <p:nvPr/>
-        </p:nvSpPr>
-        <p:spPr>
-          <a:xfrm>
-            <a:off x="713232" y="1115568"/>
-            <a:ext cx="7498080" cy="274320"/>
-          </a:xfrm>
-          <a:prstGeom prst="rect">
-            <a:avLst/>
-          </a:prstGeom>
-          <a:noFill/>
-          <a:ln/>
-        </p:spPr>
-        <p:txBody>
-          <a:bodyPr wrap="square" lIns="254" tIns="254" rIns="254" bIns="254" rtlCol="0" anchor="t">
-            <a:normAutofit/>
-          </a:bodyPr>
-          <a:lstStyle/>
-          <a:p>
-            <a:pPr indent="0" marL="0">
-              <a:buNone/>
-            </a:pPr>
-            <a:r>
-              <a:rPr lang="en-US" sz="1550" b="1" dirty="0">
-                <a:solidFill>
-                  <a:srgbClr val="0F766E"/>
-                </a:solidFill>
-                <a:latin typeface="Malgun Gothic" pitchFamily="34" charset="0"/>
-                <a:ea typeface="Malgun Gothic" pitchFamily="34" charset="-122"/>
-                <a:cs typeface="Malgun Gothic" pitchFamily="34" charset="-120"/>
-              </a:rPr>
               <a:t>누가 실행할지는 입력 핸들러 밖에서 결정한다.</a:t>
             </a:r>
             <a:endParaRPr lang="en-US" sz="1550" dirty="0"/>
@@ -8185,7 +7898,7 @@
       </p:sp>
       <p:sp>
         <p:nvSpPr>
-          <p:cNvPr id="9" name="Shape 7"/>
+          <p:cNvPr id="8" name="Shape 6"/>
           <p:cNvSpPr/>
           <p:nvPr/>
         </p:nvSpPr>
@@ -8214,7 +7927,7 @@
       </p:sp>
       <p:sp>
         <p:nvSpPr>
-          <p:cNvPr id="10" name="Text 8"/>
+          <p:cNvPr id="9" name="Text 7"/>
           <p:cNvSpPr/>
           <p:nvPr/>
         </p:nvSpPr>
@@ -8553,17 +8266,17 @@
         </p:nvSpPr>
         <p:spPr>
           <a:xfrm>
-            <a:off x="612648" y="822960"/>
-            <a:ext cx="7498080" cy="228600"/>
-          </a:xfrm>
-          <a:prstGeom prst="rect">
-            <a:avLst/>
-          </a:prstGeom>
-          <a:noFill/>
-          <a:ln/>
-        </p:spPr>
-        <p:txBody>
-          <a:bodyPr wrap="square" lIns="0" tIns="0" rIns="0" bIns="0" rtlCol="0" anchor="ctr">
+            <a:off x="749808" y="1335024"/>
+            <a:ext cx="7498080" cy="512064"/>
+          </a:xfrm>
+          <a:prstGeom prst="rect">
+            <a:avLst/>
+          </a:prstGeom>
+          <a:noFill/>
+          <a:ln/>
+        </p:spPr>
+        <p:txBody>
+          <a:bodyPr wrap="square" lIns="254" tIns="254" rIns="254" bIns="254" rtlCol="0" anchor="t">
             <a:normAutofit/>
           </a:bodyPr>
           <a:lstStyle/>
@@ -8572,55 +8285,14 @@
               <a:buNone/>
             </a:pPr>
             <a:r>
-              <a:rPr lang="en-US" sz="1150" dirty="0">
-                <a:solidFill>
-                  <a:srgbClr val="606B78"/>
+              <a:rPr lang="en-US" sz="1840" b="1" dirty="0">
+                <a:solidFill>
+                  <a:srgbClr val="17212B"/>
                 </a:solidFill>
                 <a:latin typeface="Malgun Gothic" pitchFamily="34" charset="0"/>
                 <a:ea typeface="Malgun Gothic" pitchFamily="34" charset="-122"/>
                 <a:cs typeface="Malgun Gothic" pitchFamily="34" charset="-120"/>
               </a:rPr>
-              <a:t>Command 생산자와 소비자를 분리한다</a:t>
-            </a:r>
-            <a:endParaRPr lang="en-US" sz="1150" dirty="0"/>
-          </a:p>
-        </p:txBody>
-      </p:sp>
-      <p:sp>
-        <p:nvSpPr>
-          <p:cNvPr id="8" name="Text 6"/>
-          <p:cNvSpPr/>
-          <p:nvPr/>
-        </p:nvSpPr>
-        <p:spPr>
-          <a:xfrm>
-            <a:off x="749808" y="1335024"/>
-            <a:ext cx="7498080" cy="512064"/>
-          </a:xfrm>
-          <a:prstGeom prst="rect">
-            <a:avLst/>
-          </a:prstGeom>
-          <a:noFill/>
-          <a:ln/>
-        </p:spPr>
-        <p:txBody>
-          <a:bodyPr wrap="square" lIns="254" tIns="254" rIns="254" bIns="254" rtlCol="0" anchor="t">
-            <a:normAutofit/>
-          </a:bodyPr>
-          <a:lstStyle/>
-          <a:p>
-            <a:pPr indent="0" marL="0">
-              <a:buNone/>
-            </a:pPr>
-            <a:r>
-              <a:rPr lang="en-US" sz="1840" b="1" dirty="0">
-                <a:solidFill>
-                  <a:srgbClr val="17212B"/>
-                </a:solidFill>
-                <a:latin typeface="Malgun Gothic" pitchFamily="34" charset="0"/>
-                <a:ea typeface="Malgun Gothic" pitchFamily="34" charset="-122"/>
-                <a:cs typeface="Malgun Gothic" pitchFamily="34" charset="-120"/>
-              </a:rPr>
               <a:t>누가 명령을 만들었는지와 누가 실행하는지는 별개다.</a:t>
             </a:r>
             <a:endParaRPr lang="en-US" sz="1840" dirty="0"/>
@@ -8629,7 +8301,7 @@
       </p:sp>
       <p:sp>
         <p:nvSpPr>
-          <p:cNvPr id="9" name="Shape 7"/>
+          <p:cNvPr id="8" name="Shape 6"/>
           <p:cNvSpPr/>
           <p:nvPr/>
         </p:nvSpPr>
@@ -8656,7 +8328,7 @@
       </p:sp>
       <p:sp>
         <p:nvSpPr>
-          <p:cNvPr id="10" name="Text 8"/>
+          <p:cNvPr id="9" name="Text 7"/>
           <p:cNvSpPr/>
           <p:nvPr/>
         </p:nvSpPr>
@@ -8697,7 +8369,7 @@
       </p:sp>
       <p:sp>
         <p:nvSpPr>
-          <p:cNvPr id="11" name="Text 9"/>
+          <p:cNvPr id="10" name="Text 8"/>
           <p:cNvSpPr/>
           <p:nvPr/>
         </p:nvSpPr>
@@ -8733,7 +8405,7 @@
       </p:sp>
       <p:sp>
         <p:nvSpPr>
-          <p:cNvPr id="12" name="Shape 10"/>
+          <p:cNvPr id="11" name="Shape 9"/>
           <p:cNvSpPr/>
           <p:nvPr/>
         </p:nvSpPr>
@@ -8760,7 +8432,7 @@
       </p:sp>
       <p:sp>
         <p:nvSpPr>
-          <p:cNvPr id="13" name="Text 11"/>
+          <p:cNvPr id="12" name="Text 10"/>
           <p:cNvSpPr/>
           <p:nvPr/>
         </p:nvSpPr>
@@ -8801,7 +8473,7 @@
       </p:sp>
       <p:sp>
         <p:nvSpPr>
-          <p:cNvPr id="14" name="Text 12"/>
+          <p:cNvPr id="13" name="Text 11"/>
           <p:cNvSpPr/>
           <p:nvPr/>
         </p:nvSpPr>
@@ -8837,7 +8509,7 @@
       </p:sp>
       <p:sp>
         <p:nvSpPr>
-          <p:cNvPr id="15" name="Shape 13"/>
+          <p:cNvPr id="14" name="Shape 12"/>
           <p:cNvSpPr/>
           <p:nvPr/>
         </p:nvSpPr>
@@ -8864,7 +8536,7 @@
       </p:sp>
       <p:sp>
         <p:nvSpPr>
-          <p:cNvPr id="16" name="Text 14"/>
+          <p:cNvPr id="15" name="Text 13"/>
           <p:cNvSpPr/>
           <p:nvPr/>
         </p:nvSpPr>
@@ -8905,7 +8577,7 @@
       </p:sp>
       <p:sp>
         <p:nvSpPr>
-          <p:cNvPr id="17" name="Text 15"/>
+          <p:cNvPr id="16" name="Text 14"/>
           <p:cNvSpPr/>
           <p:nvPr/>
         </p:nvSpPr>
@@ -8941,7 +8613,7 @@
       </p:sp>
       <p:sp>
         <p:nvSpPr>
-          <p:cNvPr id="18" name="Shape 16"/>
+          <p:cNvPr id="17" name="Shape 15"/>
           <p:cNvSpPr/>
           <p:nvPr/>
         </p:nvSpPr>
@@ -8968,7 +8640,7 @@
       </p:sp>
       <p:sp>
         <p:nvSpPr>
-          <p:cNvPr id="19" name="Text 17"/>
+          <p:cNvPr id="18" name="Text 16"/>
           <p:cNvSpPr/>
           <p:nvPr/>
         </p:nvSpPr>
@@ -9009,7 +8681,7 @@
       </p:sp>
       <p:sp>
         <p:nvSpPr>
-          <p:cNvPr id="20" name="Shape 18"/>
+          <p:cNvPr id="19" name="Shape 17"/>
           <p:cNvSpPr/>
           <p:nvPr/>
         </p:nvSpPr>
@@ -9034,7 +8706,7 @@
       </p:sp>
       <p:sp>
         <p:nvSpPr>
-          <p:cNvPr id="21" name="Text 19"/>
+          <p:cNvPr id="20" name="Text 18"/>
           <p:cNvSpPr/>
           <p:nvPr/>
         </p:nvSpPr>
@@ -9075,7 +8747,7 @@
       </p:sp>
       <p:sp>
         <p:nvSpPr>
-          <p:cNvPr id="22" name="Shape 20"/>
+          <p:cNvPr id="21" name="Shape 19"/>
           <p:cNvSpPr/>
           <p:nvPr/>
         </p:nvSpPr>
@@ -9100,7 +8772,7 @@
       </p:sp>
       <p:sp>
         <p:nvSpPr>
-          <p:cNvPr id="23" name="Text 21"/>
+          <p:cNvPr id="22" name="Text 20"/>
           <p:cNvSpPr/>
           <p:nvPr/>
         </p:nvSpPr>
@@ -9348,17 +9020,17 @@
         </p:nvSpPr>
         <p:spPr>
           <a:xfrm>
-            <a:off x="612648" y="822960"/>
-            <a:ext cx="7498080" cy="228600"/>
-          </a:xfrm>
-          <a:prstGeom prst="rect">
-            <a:avLst/>
-          </a:prstGeom>
-          <a:noFill/>
-          <a:ln/>
-        </p:spPr>
-        <p:txBody>
-          <a:bodyPr wrap="square" lIns="0" tIns="0" rIns="0" bIns="0" rtlCol="0" anchor="ctr">
+            <a:off x="749808" y="1335024"/>
+            <a:ext cx="7498080" cy="512064"/>
+          </a:xfrm>
+          <a:prstGeom prst="rect">
+            <a:avLst/>
+          </a:prstGeom>
+          <a:noFill/>
+          <a:ln/>
+        </p:spPr>
+        <p:txBody>
+          <a:bodyPr wrap="square" lIns="254" tIns="254" rIns="254" bIns="254" rtlCol="0" anchor="t">
             <a:normAutofit/>
           </a:bodyPr>
           <a:lstStyle/>
@@ -9367,55 +9039,14 @@
               <a:buNone/>
             </a:pPr>
             <a:r>
-              <a:rPr lang="en-US" sz="1150" dirty="0">
-                <a:solidFill>
-                  <a:srgbClr val="606B78"/>
+              <a:rPr lang="en-US" sz="1840" b="1" dirty="0">
+                <a:solidFill>
+                  <a:srgbClr val="17212B"/>
                 </a:solidFill>
                 <a:latin typeface="Malgun Gothic" pitchFamily="34" charset="0"/>
                 <a:ea typeface="Malgun Gothic" pitchFamily="34" charset="-122"/>
                 <a:cs typeface="Malgun Gothic" pitchFamily="34" charset="-120"/>
               </a:rPr>
-              <a:t>명령을 큐처럼 흘려보낸다</a:t>
-            </a:r>
-            <a:endParaRPr lang="en-US" sz="1150" dirty="0"/>
-          </a:p>
-        </p:txBody>
-      </p:sp>
-      <p:sp>
-        <p:nvSpPr>
-          <p:cNvPr id="8" name="Text 6"/>
-          <p:cNvSpPr/>
-          <p:nvPr/>
-        </p:nvSpPr>
-        <p:spPr>
-          <a:xfrm>
-            <a:off x="749808" y="1335024"/>
-            <a:ext cx="7498080" cy="512064"/>
-          </a:xfrm>
-          <a:prstGeom prst="rect">
-            <a:avLst/>
-          </a:prstGeom>
-          <a:noFill/>
-          <a:ln/>
-        </p:spPr>
-        <p:txBody>
-          <a:bodyPr wrap="square" lIns="254" tIns="254" rIns="254" bIns="254" rtlCol="0" anchor="t">
-            <a:normAutofit/>
-          </a:bodyPr>
-          <a:lstStyle/>
-          <a:p>
-            <a:pPr indent="0" marL="0">
-              <a:buNone/>
-            </a:pPr>
-            <a:r>
-              <a:rPr lang="en-US" sz="1840" b="1" dirty="0">
-                <a:solidFill>
-                  <a:srgbClr val="17212B"/>
-                </a:solidFill>
-                <a:latin typeface="Malgun Gothic" pitchFamily="34" charset="0"/>
-                <a:ea typeface="Malgun Gothic" pitchFamily="34" charset="-122"/>
-                <a:cs typeface="Malgun Gothic" pitchFamily="34" charset="-120"/>
-              </a:rPr>
               <a:t>Command는 객체이므로 저장, 전달, 지연 실행할 수 있다.</a:t>
             </a:r>
             <a:endParaRPr lang="en-US" sz="1840" dirty="0"/>
@@ -9424,7 +9055,7 @@
       </p:sp>
       <p:sp>
         <p:nvSpPr>
-          <p:cNvPr id="9" name="Shape 7"/>
+          <p:cNvPr id="8" name="Shape 6"/>
           <p:cNvSpPr/>
           <p:nvPr/>
         </p:nvSpPr>
@@ -9451,7 +9082,7 @@
       </p:sp>
       <p:sp>
         <p:nvSpPr>
-          <p:cNvPr id="10" name="Text 8"/>
+          <p:cNvPr id="9" name="Text 7"/>
           <p:cNvSpPr/>
           <p:nvPr/>
         </p:nvSpPr>
@@ -9492,7 +9123,7 @@
       </p:sp>
       <p:sp>
         <p:nvSpPr>
-          <p:cNvPr id="11" name="Text 9"/>
+          <p:cNvPr id="10" name="Text 8"/>
           <p:cNvSpPr/>
           <p:nvPr/>
         </p:nvSpPr>
@@ -9528,7 +9159,7 @@
       </p:sp>
       <p:sp>
         <p:nvSpPr>
-          <p:cNvPr id="12" name="Shape 10"/>
+          <p:cNvPr id="11" name="Shape 9"/>
           <p:cNvSpPr/>
           <p:nvPr/>
         </p:nvSpPr>
@@ -9555,7 +9186,7 @@
       </p:sp>
       <p:sp>
         <p:nvSpPr>
-          <p:cNvPr id="13" name="Text 11"/>
+          <p:cNvPr id="12" name="Text 10"/>
           <p:cNvSpPr/>
           <p:nvPr/>
         </p:nvSpPr>
@@ -9596,7 +9227,7 @@
       </p:sp>
       <p:sp>
         <p:nvSpPr>
-          <p:cNvPr id="14" name="Text 12"/>
+          <p:cNvPr id="13" name="Text 11"/>
           <p:cNvSpPr/>
           <p:nvPr/>
         </p:nvSpPr>
@@ -9632,7 +9263,7 @@
       </p:sp>
       <p:sp>
         <p:nvSpPr>
-          <p:cNvPr id="15" name="Shape 13"/>
+          <p:cNvPr id="14" name="Shape 12"/>
           <p:cNvSpPr/>
           <p:nvPr/>
         </p:nvSpPr>
@@ -9659,7 +9290,7 @@
       </p:sp>
       <p:sp>
         <p:nvSpPr>
-          <p:cNvPr id="16" name="Text 14"/>
+          <p:cNvPr id="15" name="Text 13"/>
           <p:cNvSpPr/>
           <p:nvPr/>
         </p:nvSpPr>
@@ -9700,7 +9331,7 @@
       </p:sp>
       <p:sp>
         <p:nvSpPr>
-          <p:cNvPr id="17" name="Text 15"/>
+          <p:cNvPr id="16" name="Text 14"/>
           <p:cNvSpPr/>
           <p:nvPr/>
         </p:nvSpPr>
@@ -9736,7 +9367,7 @@
       </p:sp>
       <p:sp>
         <p:nvSpPr>
-          <p:cNvPr id="18" name="Shape 16"/>
+          <p:cNvPr id="17" name="Shape 15"/>
           <p:cNvSpPr/>
           <p:nvPr/>
         </p:nvSpPr>
@@ -9763,7 +9394,7 @@
       </p:sp>
       <p:sp>
         <p:nvSpPr>
-          <p:cNvPr id="19" name="Text 17"/>
+          <p:cNvPr id="18" name="Text 16"/>
           <p:cNvSpPr/>
           <p:nvPr/>
         </p:nvSpPr>
@@ -9804,7 +9435,7 @@
       </p:sp>
       <p:sp>
         <p:nvSpPr>
-          <p:cNvPr id="20" name="Shape 18"/>
+          <p:cNvPr id="19" name="Shape 17"/>
           <p:cNvSpPr/>
           <p:nvPr/>
         </p:nvSpPr>
@@ -9829,7 +9460,7 @@
       </p:sp>
       <p:sp>
         <p:nvSpPr>
-          <p:cNvPr id="21" name="Text 19"/>
+          <p:cNvPr id="20" name="Text 18"/>
           <p:cNvSpPr/>
           <p:nvPr/>
         </p:nvSpPr>
@@ -9870,7 +9501,7 @@
       </p:sp>
       <p:sp>
         <p:nvSpPr>
-          <p:cNvPr id="22" name="Shape 20"/>
+          <p:cNvPr id="21" name="Shape 19"/>
           <p:cNvSpPr/>
           <p:nvPr/>
         </p:nvSpPr>
@@ -9895,7 +9526,7 @@
       </p:sp>
       <p:sp>
         <p:nvSpPr>
-          <p:cNvPr id="23" name="Text 21"/>
+          <p:cNvPr id="22" name="Text 20"/>
           <p:cNvSpPr/>
           <p:nvPr/>
         </p:nvSpPr>
@@ -11017,48 +10648,7 @@
       </p:sp>
       <p:sp>
         <p:nvSpPr>
-          <p:cNvPr id="7" name="Text 5"/>
-          <p:cNvSpPr/>
-          <p:nvPr/>
-        </p:nvSpPr>
-        <p:spPr>
-          <a:xfrm>
-            <a:off x="612648" y="822960"/>
-            <a:ext cx="7498080" cy="228600"/>
-          </a:xfrm>
-          <a:prstGeom prst="rect">
-            <a:avLst/>
-          </a:prstGeom>
-          <a:noFill/>
-          <a:ln/>
-        </p:spPr>
-        <p:txBody>
-          <a:bodyPr wrap="square" lIns="0" tIns="0" rIns="0" bIns="0" rtlCol="0" anchor="ctr">
-            <a:normAutofit/>
-          </a:bodyPr>
-          <a:lstStyle/>
-          <a:p>
-            <a:pPr indent="0" marL="0">
-              <a:buNone/>
-            </a:pPr>
-            <a:r>
-              <a:rPr lang="en-US" sz="1150" dirty="0">
-                <a:solidFill>
-                  <a:srgbClr val="606B78"/>
-                </a:solidFill>
-                <a:latin typeface="Malgun Gothic" pitchFamily="34" charset="0"/>
-                <a:ea typeface="Malgun Gothic" pitchFamily="34" charset="-122"/>
-                <a:cs typeface="Malgun Gothic" pitchFamily="34" charset="-120"/>
-              </a:rPr>
-              <a:t>수업 끝에 설명하고 구현할 수 있어야 하는 것</a:t>
-            </a:r>
-            <a:endParaRPr lang="en-US" sz="1150" dirty="0"/>
-          </a:p>
-        </p:txBody>
-      </p:sp>
-      <p:sp>
-        <p:nvSpPr>
-          <p:cNvPr id="8" name="Shape 6"/>
+          <p:cNvPr id="7" name="Shape 5"/>
           <p:cNvSpPr/>
           <p:nvPr/>
         </p:nvSpPr>
@@ -11083,7 +10673,7 @@
       </p:sp>
       <p:sp>
         <p:nvSpPr>
-          <p:cNvPr id="9" name="Text 7"/>
+          <p:cNvPr id="8" name="Text 6"/>
           <p:cNvSpPr/>
           <p:nvPr/>
         </p:nvSpPr>
@@ -11124,7 +10714,7 @@
       </p:sp>
       <p:sp>
         <p:nvSpPr>
-          <p:cNvPr id="10" name="Shape 8"/>
+          <p:cNvPr id="9" name="Shape 7"/>
           <p:cNvSpPr/>
           <p:nvPr/>
         </p:nvSpPr>
@@ -11149,7 +10739,7 @@
       </p:sp>
       <p:sp>
         <p:nvSpPr>
-          <p:cNvPr id="11" name="Text 9"/>
+          <p:cNvPr id="10" name="Text 8"/>
           <p:cNvSpPr/>
           <p:nvPr/>
         </p:nvSpPr>
@@ -11190,7 +10780,7 @@
       </p:sp>
       <p:sp>
         <p:nvSpPr>
-          <p:cNvPr id="12" name="Shape 10"/>
+          <p:cNvPr id="11" name="Shape 9"/>
           <p:cNvSpPr/>
           <p:nvPr/>
         </p:nvSpPr>
@@ -11215,7 +10805,7 @@
       </p:sp>
       <p:sp>
         <p:nvSpPr>
-          <p:cNvPr id="13" name="Text 11"/>
+          <p:cNvPr id="12" name="Text 10"/>
           <p:cNvSpPr/>
           <p:nvPr/>
         </p:nvSpPr>
@@ -11256,7 +10846,7 @@
       </p:sp>
       <p:sp>
         <p:nvSpPr>
-          <p:cNvPr id="14" name="Shape 12"/>
+          <p:cNvPr id="13" name="Shape 11"/>
           <p:cNvSpPr/>
           <p:nvPr/>
         </p:nvSpPr>
@@ -11281,7 +10871,7 @@
       </p:sp>
       <p:sp>
         <p:nvSpPr>
-          <p:cNvPr id="15" name="Text 13"/>
+          <p:cNvPr id="14" name="Text 12"/>
           <p:cNvSpPr/>
           <p:nvPr/>
         </p:nvSpPr>
@@ -11529,17 +11119,17 @@
         </p:nvSpPr>
         <p:spPr>
           <a:xfrm>
-            <a:off x="612648" y="822960"/>
-            <a:ext cx="7498080" cy="228600"/>
-          </a:xfrm>
-          <a:prstGeom prst="rect">
-            <a:avLst/>
-          </a:prstGeom>
-          <a:noFill/>
-          <a:ln/>
-        </p:spPr>
-        <p:txBody>
-          <a:bodyPr wrap="square" lIns="0" tIns="0" rIns="0" bIns="0" rtlCol="0" anchor="ctr">
+            <a:off x="713232" y="1115568"/>
+            <a:ext cx="7498080" cy="274320"/>
+          </a:xfrm>
+          <a:prstGeom prst="rect">
+            <a:avLst/>
+          </a:prstGeom>
+          <a:noFill/>
+          <a:ln/>
+        </p:spPr>
+        <p:txBody>
+          <a:bodyPr wrap="square" lIns="254" tIns="254" rIns="254" bIns="254" rtlCol="0" anchor="t">
             <a:normAutofit/>
           </a:bodyPr>
           <a:lstStyle/>
@@ -11548,55 +11138,14 @@
               <a:buNone/>
             </a:pPr>
             <a:r>
-              <a:rPr lang="en-US" sz="1150" dirty="0">
-                <a:solidFill>
-                  <a:srgbClr val="606B78"/>
+              <a:rPr lang="en-US" sz="1550" b="1" dirty="0">
+                <a:solidFill>
+                  <a:srgbClr val="0F766E"/>
                 </a:solidFill>
                 <a:latin typeface="Malgun Gothic" pitchFamily="34" charset="0"/>
                 <a:ea typeface="Malgun Gothic" pitchFamily="34" charset="-122"/>
                 <a:cs typeface="Malgun Gothic" pitchFamily="34" charset="-120"/>
               </a:rPr>
-              <a:t>실행과 되돌리기를 한 쌍으로 둔다</a:t>
-            </a:r>
-            <a:endParaRPr lang="en-US" sz="1150" dirty="0"/>
-          </a:p>
-        </p:txBody>
-      </p:sp>
-      <p:sp>
-        <p:nvSpPr>
-          <p:cNvPr id="8" name="Text 6"/>
-          <p:cNvSpPr/>
-          <p:nvPr/>
-        </p:nvSpPr>
-        <p:spPr>
-          <a:xfrm>
-            <a:off x="713232" y="1115568"/>
-            <a:ext cx="7498080" cy="274320"/>
-          </a:xfrm>
-          <a:prstGeom prst="rect">
-            <a:avLst/>
-          </a:prstGeom>
-          <a:noFill/>
-          <a:ln/>
-        </p:spPr>
-        <p:txBody>
-          <a:bodyPr wrap="square" lIns="254" tIns="254" rIns="254" bIns="254" rtlCol="0" anchor="t">
-            <a:normAutofit/>
-          </a:bodyPr>
-          <a:lstStyle/>
-          <a:p>
-            <a:pPr indent="0" marL="0">
-              <a:buNone/>
-            </a:pPr>
-            <a:r>
-              <a:rPr lang="en-US" sz="1550" b="1" dirty="0">
-                <a:solidFill>
-                  <a:srgbClr val="0F766E"/>
-                </a:solidFill>
-                <a:latin typeface="Malgun Gothic" pitchFamily="34" charset="0"/>
-                <a:ea typeface="Malgun Gothic" pitchFamily="34" charset="-122"/>
-                <a:cs typeface="Malgun Gothic" pitchFamily="34" charset="-120"/>
-              </a:rPr>
               <a:t>되돌릴 수 있는 명령은 Execute와 Undo를 가진다.</a:t>
             </a:r>
             <a:endParaRPr lang="en-US" sz="1550" dirty="0"/>
@@ -11605,7 +11154,7 @@
       </p:sp>
       <p:sp>
         <p:nvSpPr>
-          <p:cNvPr id="9" name="Shape 7"/>
+          <p:cNvPr id="8" name="Shape 6"/>
           <p:cNvSpPr/>
           <p:nvPr/>
         </p:nvSpPr>
@@ -11634,7 +11183,7 @@
       </p:sp>
       <p:sp>
         <p:nvSpPr>
-          <p:cNvPr id="10" name="Text 8"/>
+          <p:cNvPr id="9" name="Text 7"/>
           <p:cNvSpPr/>
           <p:nvPr/>
         </p:nvSpPr>
@@ -11950,17 +11499,17 @@
         </p:nvSpPr>
         <p:spPr>
           <a:xfrm>
-            <a:off x="612648" y="822960"/>
-            <a:ext cx="7498080" cy="228600"/>
-          </a:xfrm>
-          <a:prstGeom prst="rect">
-            <a:avLst/>
-          </a:prstGeom>
-          <a:noFill/>
-          <a:ln/>
-        </p:spPr>
-        <p:txBody>
-          <a:bodyPr wrap="square" lIns="0" tIns="0" rIns="0" bIns="0" rtlCol="0" anchor="ctr">
+            <a:off x="713232" y="1115568"/>
+            <a:ext cx="7498080" cy="274320"/>
+          </a:xfrm>
+          <a:prstGeom prst="rect">
+            <a:avLst/>
+          </a:prstGeom>
+          <a:noFill/>
+          <a:ln/>
+        </p:spPr>
+        <p:txBody>
+          <a:bodyPr wrap="square" lIns="254" tIns="254" rIns="254" bIns="254" rtlCol="0" anchor="t">
             <a:normAutofit/>
           </a:bodyPr>
           <a:lstStyle/>
@@ -11969,55 +11518,14 @@
               <a:buNone/>
             </a:pPr>
             <a:r>
-              <a:rPr lang="en-US" sz="1150" dirty="0">
-                <a:solidFill>
-                  <a:srgbClr val="606B78"/>
+              <a:rPr lang="en-US" sz="1550" b="1" dirty="0">
+                <a:solidFill>
+                  <a:srgbClr val="0F766E"/>
                 </a:solidFill>
                 <a:latin typeface="Malgun Gothic" pitchFamily="34" charset="0"/>
                 <a:ea typeface="Malgun Gothic" pitchFamily="34" charset="-122"/>
                 <a:cs typeface="Malgun Gothic" pitchFamily="34" charset="-120"/>
               </a:rPr>
-              <a:t>한 번의 이동 사건을 객체로 저장한다</a:t>
-            </a:r>
-            <a:endParaRPr lang="en-US" sz="1150" dirty="0"/>
-          </a:p>
-        </p:txBody>
-      </p:sp>
-      <p:sp>
-        <p:nvSpPr>
-          <p:cNvPr id="8" name="Text 6"/>
-          <p:cNvSpPr/>
-          <p:nvPr/>
-        </p:nvSpPr>
-        <p:spPr>
-          <a:xfrm>
-            <a:off x="713232" y="1115568"/>
-            <a:ext cx="7498080" cy="274320"/>
-          </a:xfrm>
-          <a:prstGeom prst="rect">
-            <a:avLst/>
-          </a:prstGeom>
-          <a:noFill/>
-          <a:ln/>
-        </p:spPr>
-        <p:txBody>
-          <a:bodyPr wrap="square" lIns="254" tIns="254" rIns="254" bIns="254" rtlCol="0" anchor="t">
-            <a:normAutofit/>
-          </a:bodyPr>
-          <a:lstStyle/>
-          <a:p>
-            <a:pPr indent="0" marL="0">
-              <a:buNone/>
-            </a:pPr>
-            <a:r>
-              <a:rPr lang="en-US" sz="1550" b="1" dirty="0">
-                <a:solidFill>
-                  <a:srgbClr val="0F766E"/>
-                </a:solidFill>
-                <a:latin typeface="Malgun Gothic" pitchFamily="34" charset="0"/>
-                <a:ea typeface="Malgun Gothic" pitchFamily="34" charset="-122"/>
-                <a:cs typeface="Malgun Gothic" pitchFamily="34" charset="-120"/>
-              </a:rPr>
               <a:t>대상, 목적지, 이전 위치를 필드로 가진다.</a:t>
             </a:r>
             <a:endParaRPr lang="en-US" sz="1550" dirty="0"/>
@@ -12026,7 +11534,7 @@
       </p:sp>
       <p:sp>
         <p:nvSpPr>
-          <p:cNvPr id="9" name="Shape 7"/>
+          <p:cNvPr id="8" name="Shape 6"/>
           <p:cNvSpPr/>
           <p:nvPr/>
         </p:nvSpPr>
@@ -12055,7 +11563,7 @@
       </p:sp>
       <p:sp>
         <p:nvSpPr>
-          <p:cNvPr id="10" name="Text 8"/>
+          <p:cNvPr id="9" name="Text 7"/>
           <p:cNvSpPr/>
           <p:nvPr/>
         </p:nvSpPr>
@@ -12388,17 +11896,17 @@
         </p:nvSpPr>
         <p:spPr>
           <a:xfrm>
-            <a:off x="612648" y="822960"/>
-            <a:ext cx="7498080" cy="228600"/>
-          </a:xfrm>
-          <a:prstGeom prst="rect">
-            <a:avLst/>
-          </a:prstGeom>
-          <a:noFill/>
-          <a:ln/>
-        </p:spPr>
-        <p:txBody>
-          <a:bodyPr wrap="square" lIns="0" tIns="0" rIns="0" bIns="0" rtlCol="0" anchor="ctr">
+            <a:off x="713232" y="1115568"/>
+            <a:ext cx="7498080" cy="274320"/>
+          </a:xfrm>
+          <a:prstGeom prst="rect">
+            <a:avLst/>
+          </a:prstGeom>
+          <a:noFill/>
+          <a:ln/>
+        </p:spPr>
+        <p:txBody>
+          <a:bodyPr wrap="square" lIns="254" tIns="254" rIns="254" bIns="254" rtlCol="0" anchor="t">
             <a:normAutofit/>
           </a:bodyPr>
           <a:lstStyle/>
@@ -12407,55 +11915,14 @@
               <a:buNone/>
             </a:pPr>
             <a:r>
-              <a:rPr lang="en-US" sz="1150" dirty="0">
-                <a:solidFill>
-                  <a:srgbClr val="606B78"/>
+              <a:rPr lang="en-US" sz="1550" b="1" dirty="0">
+                <a:solidFill>
+                  <a:srgbClr val="0F766E"/>
                 </a:solidFill>
                 <a:latin typeface="Malgun Gothic" pitchFamily="34" charset="0"/>
                 <a:ea typeface="Malgun Gothic" pitchFamily="34" charset="-122"/>
                 <a:cs typeface="Malgun Gothic" pitchFamily="34" charset="-120"/>
               </a:rPr>
-              <a:t>바뀐 최소 상태만 기억한다</a:t>
-            </a:r>
-            <a:endParaRPr lang="en-US" sz="1150" dirty="0"/>
-          </a:p>
-        </p:txBody>
-      </p:sp>
-      <p:sp>
-        <p:nvSpPr>
-          <p:cNvPr id="8" name="Text 6"/>
-          <p:cNvSpPr/>
-          <p:nvPr/>
-        </p:nvSpPr>
-        <p:spPr>
-          <a:xfrm>
-            <a:off x="713232" y="1115568"/>
-            <a:ext cx="7498080" cy="274320"/>
-          </a:xfrm>
-          <a:prstGeom prst="rect">
-            <a:avLst/>
-          </a:prstGeom>
-          <a:noFill/>
-          <a:ln/>
-        </p:spPr>
-        <p:txBody>
-          <a:bodyPr wrap="square" lIns="254" tIns="254" rIns="254" bIns="254" rtlCol="0" anchor="t">
-            <a:normAutofit/>
-          </a:bodyPr>
-          <a:lstStyle/>
-          <a:p>
-            <a:pPr indent="0" marL="0">
-              <a:buNone/>
-            </a:pPr>
-            <a:r>
-              <a:rPr lang="en-US" sz="1550" b="1" dirty="0">
-                <a:solidFill>
-                  <a:srgbClr val="0F766E"/>
-                </a:solidFill>
-                <a:latin typeface="Malgun Gothic" pitchFamily="34" charset="0"/>
-                <a:ea typeface="Malgun Gothic" pitchFamily="34" charset="-122"/>
-                <a:cs typeface="Malgun Gothic" pitchFamily="34" charset="-120"/>
-              </a:rPr>
               <a:t>이동 명령은 이전 위치만 저장해도 되돌릴 수 있다.</a:t>
             </a:r>
             <a:endParaRPr lang="en-US" sz="1550" dirty="0"/>
@@ -12464,7 +11931,7 @@
       </p:sp>
       <p:sp>
         <p:nvSpPr>
-          <p:cNvPr id="9" name="Shape 7"/>
+          <p:cNvPr id="8" name="Shape 6"/>
           <p:cNvSpPr/>
           <p:nvPr/>
         </p:nvSpPr>
@@ -12493,7 +11960,7 @@
       </p:sp>
       <p:sp>
         <p:nvSpPr>
-          <p:cNvPr id="10" name="Text 8"/>
+          <p:cNvPr id="9" name="Text 7"/>
           <p:cNvSpPr/>
           <p:nvPr/>
         </p:nvSpPr>
@@ -12883,17 +12350,17 @@
         </p:nvSpPr>
         <p:spPr>
           <a:xfrm>
-            <a:off x="612648" y="822960"/>
-            <a:ext cx="7498080" cy="228600"/>
-          </a:xfrm>
-          <a:prstGeom prst="rect">
-            <a:avLst/>
-          </a:prstGeom>
-          <a:noFill/>
-          <a:ln/>
-        </p:spPr>
-        <p:txBody>
-          <a:bodyPr wrap="square" lIns="0" tIns="0" rIns="0" bIns="0" rtlCol="0" anchor="ctr">
+            <a:off x="713232" y="1115568"/>
+            <a:ext cx="7498080" cy="274320"/>
+          </a:xfrm>
+          <a:prstGeom prst="rect">
+            <a:avLst/>
+          </a:prstGeom>
+          <a:noFill/>
+          <a:ln/>
+        </p:spPr>
+        <p:txBody>
+          <a:bodyPr wrap="square" lIns="254" tIns="254" rIns="254" bIns="254" rtlCol="0" anchor="t">
             <a:normAutofit/>
           </a:bodyPr>
           <a:lstStyle/>
@@ -12902,55 +12369,14 @@
               <a:buNone/>
             </a:pPr>
             <a:r>
-              <a:rPr lang="en-US" sz="1150" dirty="0">
-                <a:solidFill>
-                  <a:srgbClr val="606B78"/>
+              <a:rPr lang="en-US" sz="1550" b="1" dirty="0">
+                <a:solidFill>
+                  <a:srgbClr val="0F766E"/>
                 </a:solidFill>
                 <a:latin typeface="Malgun Gothic" pitchFamily="34" charset="0"/>
                 <a:ea typeface="Malgun Gothic" pitchFamily="34" charset="-122"/>
                 <a:cs typeface="Malgun Gothic" pitchFamily="34" charset="-120"/>
               </a:rPr>
-              <a:t>명령 하나가 히스토리 항목 하나가 된다</a:t>
-            </a:r>
-            <a:endParaRPr lang="en-US" sz="1150" dirty="0"/>
-          </a:p>
-        </p:txBody>
-      </p:sp>
-      <p:sp>
-        <p:nvSpPr>
-          <p:cNvPr id="8" name="Text 6"/>
-          <p:cNvSpPr/>
-          <p:nvPr/>
-        </p:nvSpPr>
-        <p:spPr>
-          <a:xfrm>
-            <a:off x="713232" y="1115568"/>
-            <a:ext cx="7498080" cy="274320"/>
-          </a:xfrm>
-          <a:prstGeom prst="rect">
-            <a:avLst/>
-          </a:prstGeom>
-          <a:noFill/>
-          <a:ln/>
-        </p:spPr>
-        <p:txBody>
-          <a:bodyPr wrap="square" lIns="254" tIns="254" rIns="254" bIns="254" rtlCol="0" anchor="t">
-            <a:normAutofit/>
-          </a:bodyPr>
-          <a:lstStyle/>
-          <a:p>
-            <a:pPr indent="0" marL="0">
-              <a:buNone/>
-            </a:pPr>
-            <a:r>
-              <a:rPr lang="en-US" sz="1550" b="1" dirty="0">
-                <a:solidFill>
-                  <a:srgbClr val="0F766E"/>
-                </a:solidFill>
-                <a:latin typeface="Malgun Gothic" pitchFamily="34" charset="0"/>
-                <a:ea typeface="Malgun Gothic" pitchFamily="34" charset="-122"/>
-                <a:cs typeface="Malgun Gothic" pitchFamily="34" charset="-120"/>
-              </a:rPr>
               <a:t>방향키 입력은 곧 MoveUnitCommand 생성이다.</a:t>
             </a:r>
             <a:endParaRPr lang="en-US" sz="1550" dirty="0"/>
@@ -12959,7 +12385,7 @@
       </p:sp>
       <p:sp>
         <p:nvSpPr>
-          <p:cNvPr id="9" name="Shape 7"/>
+          <p:cNvPr id="8" name="Shape 6"/>
           <p:cNvSpPr/>
           <p:nvPr/>
         </p:nvSpPr>
@@ -12988,7 +12414,7 @@
       </p:sp>
       <p:sp>
         <p:nvSpPr>
-          <p:cNvPr id="10" name="Text 8"/>
+          <p:cNvPr id="9" name="Text 7"/>
           <p:cNvSpPr/>
           <p:nvPr/>
         </p:nvSpPr>
@@ -13339,17 +12765,17 @@
         </p:nvSpPr>
         <p:spPr>
           <a:xfrm>
-            <a:off x="612648" y="822960"/>
-            <a:ext cx="7498080" cy="228600"/>
-          </a:xfrm>
-          <a:prstGeom prst="rect">
-            <a:avLst/>
-          </a:prstGeom>
-          <a:noFill/>
-          <a:ln/>
-        </p:spPr>
-        <p:txBody>
-          <a:bodyPr wrap="square" lIns="0" tIns="0" rIns="0" bIns="0" rtlCol="0" anchor="ctr">
+            <a:off x="713232" y="1115568"/>
+            <a:ext cx="7498080" cy="274320"/>
+          </a:xfrm>
+          <a:prstGeom prst="rect">
+            <a:avLst/>
+          </a:prstGeom>
+          <a:noFill/>
+          <a:ln/>
+        </p:spPr>
+        <p:txBody>
+          <a:bodyPr wrap="square" lIns="254" tIns="254" rIns="254" bIns="254" rtlCol="0" anchor="t">
             <a:normAutofit/>
           </a:bodyPr>
           <a:lstStyle/>
@@ -13358,55 +12784,14 @@
               <a:buNone/>
             </a:pPr>
             <a:r>
-              <a:rPr lang="en-US" sz="1150" dirty="0">
-                <a:solidFill>
-                  <a:srgbClr val="606B78"/>
+              <a:rPr lang="en-US" sz="1550" b="1" dirty="0">
+                <a:solidFill>
+                  <a:srgbClr val="0F766E"/>
                 </a:solidFill>
                 <a:latin typeface="Malgun Gothic" pitchFamily="34" charset="0"/>
                 <a:ea typeface="Malgun Gothic" pitchFamily="34" charset="-122"/>
                 <a:cs typeface="Malgun Gothic" pitchFamily="34" charset="-120"/>
               </a:rPr>
-              <a:t>새 명령은 Redo 후보를 지운다</a:t>
-            </a:r>
-            <a:endParaRPr lang="en-US" sz="1150" dirty="0"/>
-          </a:p>
-        </p:txBody>
-      </p:sp>
-      <p:sp>
-        <p:nvSpPr>
-          <p:cNvPr id="8" name="Text 6"/>
-          <p:cNvSpPr/>
-          <p:nvPr/>
-        </p:nvSpPr>
-        <p:spPr>
-          <a:xfrm>
-            <a:off x="713232" y="1115568"/>
-            <a:ext cx="7498080" cy="274320"/>
-          </a:xfrm>
-          <a:prstGeom prst="rect">
-            <a:avLst/>
-          </a:prstGeom>
-          <a:noFill/>
-          <a:ln/>
-        </p:spPr>
-        <p:txBody>
-          <a:bodyPr wrap="square" lIns="254" tIns="254" rIns="254" bIns="254" rtlCol="0" anchor="t">
-            <a:normAutofit/>
-          </a:bodyPr>
-          <a:lstStyle/>
-          <a:p>
-            <a:pPr indent="0" marL="0">
-              <a:buNone/>
-            </a:pPr>
-            <a:r>
-              <a:rPr lang="en-US" sz="1550" b="1" dirty="0">
-                <a:solidFill>
-                  <a:srgbClr val="0F766E"/>
-                </a:solidFill>
-                <a:latin typeface="Malgun Gothic" pitchFamily="34" charset="0"/>
-                <a:ea typeface="Malgun Gothic" pitchFamily="34" charset="-122"/>
-                <a:cs typeface="Malgun Gothic" pitchFamily="34" charset="-120"/>
-              </a:rPr>
               <a:t>Undo 후 새 행동을 하면 미래 기록은 무효가 된다.</a:t>
             </a:r>
             <a:endParaRPr lang="en-US" sz="1550" dirty="0"/>
@@ -13415,7 +12800,7 @@
       </p:sp>
       <p:sp>
         <p:nvSpPr>
-          <p:cNvPr id="9" name="Shape 7"/>
+          <p:cNvPr id="8" name="Shape 6"/>
           <p:cNvSpPr/>
           <p:nvPr/>
         </p:nvSpPr>
@@ -13444,7 +12829,7 @@
       </p:sp>
       <p:sp>
         <p:nvSpPr>
-          <p:cNvPr id="10" name="Text 8"/>
+          <p:cNvPr id="9" name="Text 7"/>
           <p:cNvSpPr/>
           <p:nvPr/>
         </p:nvSpPr>
@@ -13834,17 +13219,17 @@
         </p:nvSpPr>
         <p:spPr>
           <a:xfrm>
-            <a:off x="612648" y="822960"/>
-            <a:ext cx="7498080" cy="228600"/>
-          </a:xfrm>
-          <a:prstGeom prst="rect">
-            <a:avLst/>
-          </a:prstGeom>
-          <a:noFill/>
-          <a:ln/>
-        </p:spPr>
-        <p:txBody>
-          <a:bodyPr wrap="square" lIns="0" tIns="0" rIns="0" bIns="0" rtlCol="0" anchor="ctr">
+            <a:off x="713232" y="1115568"/>
+            <a:ext cx="7498080" cy="274320"/>
+          </a:xfrm>
+          <a:prstGeom prst="rect">
+            <a:avLst/>
+          </a:prstGeom>
+          <a:noFill/>
+          <a:ln/>
+        </p:spPr>
+        <p:txBody>
+          <a:bodyPr wrap="square" lIns="254" tIns="254" rIns="254" bIns="254" rtlCol="0" anchor="t">
             <a:normAutofit/>
           </a:bodyPr>
           <a:lstStyle/>
@@ -13853,55 +13238,14 @@
               <a:buNone/>
             </a:pPr>
             <a:r>
-              <a:rPr lang="en-US" sz="1150" dirty="0">
-                <a:solidFill>
-                  <a:srgbClr val="606B78"/>
+              <a:rPr lang="en-US" sz="1550" b="1" dirty="0">
+                <a:solidFill>
+                  <a:srgbClr val="0F766E"/>
                 </a:solidFill>
                 <a:latin typeface="Malgun Gothic" pitchFamily="34" charset="0"/>
                 <a:ea typeface="Malgun Gothic" pitchFamily="34" charset="-122"/>
                 <a:cs typeface="Malgun Gothic" pitchFamily="34" charset="-120"/>
               </a:rPr>
-              <a:t>현재 위치를 기준으로 앞뒤로 이동한다</a:t>
-            </a:r>
-            <a:endParaRPr lang="en-US" sz="1150" dirty="0"/>
-          </a:p>
-        </p:txBody>
-      </p:sp>
-      <p:sp>
-        <p:nvSpPr>
-          <p:cNvPr id="8" name="Text 6"/>
-          <p:cNvSpPr/>
-          <p:nvPr/>
-        </p:nvSpPr>
-        <p:spPr>
-          <a:xfrm>
-            <a:off x="713232" y="1115568"/>
-            <a:ext cx="7498080" cy="274320"/>
-          </a:xfrm>
-          <a:prstGeom prst="rect">
-            <a:avLst/>
-          </a:prstGeom>
-          <a:noFill/>
-          <a:ln/>
-        </p:spPr>
-        <p:txBody>
-          <a:bodyPr wrap="square" lIns="254" tIns="254" rIns="254" bIns="254" rtlCol="0" anchor="t">
-            <a:normAutofit/>
-          </a:bodyPr>
-          <a:lstStyle/>
-          <a:p>
-            <a:pPr indent="0" marL="0">
-              <a:buNone/>
-            </a:pPr>
-            <a:r>
-              <a:rPr lang="en-US" sz="1550" b="1" dirty="0">
-                <a:solidFill>
-                  <a:srgbClr val="0F766E"/>
-                </a:solidFill>
-                <a:latin typeface="Malgun Gothic" pitchFamily="34" charset="0"/>
-                <a:ea typeface="Malgun Gothic" pitchFamily="34" charset="-122"/>
-                <a:cs typeface="Malgun Gothic" pitchFamily="34" charset="-120"/>
-              </a:rPr>
               <a:t>히스토리는 선형 시간표처럼 다룬다.</a:t>
             </a:r>
             <a:endParaRPr lang="en-US" sz="1550" dirty="0"/>
@@ -13910,7 +13254,7 @@
       </p:sp>
       <p:sp>
         <p:nvSpPr>
-          <p:cNvPr id="9" name="Shape 7"/>
+          <p:cNvPr id="8" name="Shape 6"/>
           <p:cNvSpPr/>
           <p:nvPr/>
         </p:nvSpPr>
@@ -13939,7 +13283,7 @@
       </p:sp>
       <p:sp>
         <p:nvSpPr>
-          <p:cNvPr id="10" name="Text 8"/>
+          <p:cNvPr id="9" name="Text 7"/>
           <p:cNvSpPr/>
           <p:nvPr/>
         </p:nvSpPr>
@@ -14380,17 +13724,17 @@
         </p:nvSpPr>
         <p:spPr>
           <a:xfrm>
-            <a:off x="612648" y="822960"/>
-            <a:ext cx="7498080" cy="228600"/>
-          </a:xfrm>
-          <a:prstGeom prst="rect">
-            <a:avLst/>
-          </a:prstGeom>
-          <a:noFill/>
-          <a:ln/>
-        </p:spPr>
-        <p:txBody>
-          <a:bodyPr wrap="square" lIns="0" tIns="0" rIns="0" bIns="0" rtlCol="0" anchor="ctr">
+            <a:off x="749808" y="1335024"/>
+            <a:ext cx="7498080" cy="512064"/>
+          </a:xfrm>
+          <a:prstGeom prst="rect">
+            <a:avLst/>
+          </a:prstGeom>
+          <a:noFill/>
+          <a:ln/>
+        </p:spPr>
+        <p:txBody>
+          <a:bodyPr wrap="square" lIns="254" tIns="254" rIns="254" bIns="254" rtlCol="0" anchor="t">
             <a:normAutofit/>
           </a:bodyPr>
           <a:lstStyle/>
@@ -14399,55 +13743,14 @@
               <a:buNone/>
             </a:pPr>
             <a:r>
-              <a:rPr lang="en-US" sz="1150" dirty="0">
-                <a:solidFill>
-                  <a:srgbClr val="606B78"/>
+              <a:rPr lang="en-US" sz="1840" b="1" dirty="0">
+                <a:solidFill>
+                  <a:srgbClr val="17212B"/>
                 </a:solidFill>
                 <a:latin typeface="Malgun Gothic" pitchFamily="34" charset="0"/>
                 <a:ea typeface="Malgun Gothic" pitchFamily="34" charset="-122"/>
                 <a:cs typeface="Malgun Gothic" pitchFamily="34" charset="-120"/>
               </a:rPr>
-              <a:t>그림으로 기억하기</a:t>
-            </a:r>
-            <a:endParaRPr lang="en-US" sz="1150" dirty="0"/>
-          </a:p>
-        </p:txBody>
-      </p:sp>
-      <p:sp>
-        <p:nvSpPr>
-          <p:cNvPr id="8" name="Text 6"/>
-          <p:cNvSpPr/>
-          <p:nvPr/>
-        </p:nvSpPr>
-        <p:spPr>
-          <a:xfrm>
-            <a:off x="749808" y="1335024"/>
-            <a:ext cx="7498080" cy="512064"/>
-          </a:xfrm>
-          <a:prstGeom prst="rect">
-            <a:avLst/>
-          </a:prstGeom>
-          <a:noFill/>
-          <a:ln/>
-        </p:spPr>
-        <p:txBody>
-          <a:bodyPr wrap="square" lIns="254" tIns="254" rIns="254" bIns="254" rtlCol="0" anchor="t">
-            <a:normAutofit/>
-          </a:bodyPr>
-          <a:lstStyle/>
-          <a:p>
-            <a:pPr indent="0" marL="0">
-              <a:buNone/>
-            </a:pPr>
-            <a:r>
-              <a:rPr lang="en-US" sz="1840" b="1" dirty="0">
-                <a:solidFill>
-                  <a:srgbClr val="17212B"/>
-                </a:solidFill>
-                <a:latin typeface="Malgun Gothic" pitchFamily="34" charset="0"/>
-                <a:ea typeface="Malgun Gothic" pitchFamily="34" charset="-122"/>
-                <a:cs typeface="Malgun Gothic" pitchFamily="34" charset="-120"/>
-              </a:rPr>
               <a:t>현재보다 오른쪽은 Redo 후보이고, 새 명령이 들어오면 사라진다.</a:t>
             </a:r>
             <a:endParaRPr lang="en-US" sz="1840" dirty="0"/>
@@ -14456,7 +13759,7 @@
       </p:sp>
       <p:sp>
         <p:nvSpPr>
-          <p:cNvPr id="9" name="Shape 7"/>
+          <p:cNvPr id="8" name="Shape 6"/>
           <p:cNvSpPr/>
           <p:nvPr/>
         </p:nvSpPr>
@@ -14483,7 +13786,7 @@
       </p:sp>
       <p:sp>
         <p:nvSpPr>
-          <p:cNvPr id="10" name="Text 8"/>
+          <p:cNvPr id="9" name="Text 7"/>
           <p:cNvSpPr/>
           <p:nvPr/>
         </p:nvSpPr>
@@ -14524,7 +13827,7 @@
       </p:sp>
       <p:sp>
         <p:nvSpPr>
-          <p:cNvPr id="11" name="Text 9"/>
+          <p:cNvPr id="10" name="Text 8"/>
           <p:cNvSpPr/>
           <p:nvPr/>
         </p:nvSpPr>
@@ -14560,7 +13863,7 @@
       </p:sp>
       <p:sp>
         <p:nvSpPr>
-          <p:cNvPr id="12" name="Shape 10"/>
+          <p:cNvPr id="11" name="Shape 9"/>
           <p:cNvSpPr/>
           <p:nvPr/>
         </p:nvSpPr>
@@ -14587,7 +13890,7 @@
       </p:sp>
       <p:sp>
         <p:nvSpPr>
-          <p:cNvPr id="13" name="Text 11"/>
+          <p:cNvPr id="12" name="Text 10"/>
           <p:cNvSpPr/>
           <p:nvPr/>
         </p:nvSpPr>
@@ -14628,7 +13931,7 @@
       </p:sp>
       <p:sp>
         <p:nvSpPr>
-          <p:cNvPr id="14" name="Text 12"/>
+          <p:cNvPr id="13" name="Text 11"/>
           <p:cNvSpPr/>
           <p:nvPr/>
         </p:nvSpPr>
@@ -14664,7 +13967,7 @@
       </p:sp>
       <p:sp>
         <p:nvSpPr>
-          <p:cNvPr id="15" name="Shape 13"/>
+          <p:cNvPr id="14" name="Shape 12"/>
           <p:cNvSpPr/>
           <p:nvPr/>
         </p:nvSpPr>
@@ -14691,7 +13994,7 @@
       </p:sp>
       <p:sp>
         <p:nvSpPr>
-          <p:cNvPr id="16" name="Text 14"/>
+          <p:cNvPr id="15" name="Text 13"/>
           <p:cNvSpPr/>
           <p:nvPr/>
         </p:nvSpPr>
@@ -14732,7 +14035,7 @@
       </p:sp>
       <p:sp>
         <p:nvSpPr>
-          <p:cNvPr id="17" name="Text 15"/>
+          <p:cNvPr id="16" name="Text 14"/>
           <p:cNvSpPr/>
           <p:nvPr/>
         </p:nvSpPr>
@@ -14768,7 +14071,7 @@
       </p:sp>
       <p:sp>
         <p:nvSpPr>
-          <p:cNvPr id="18" name="Shape 16"/>
+          <p:cNvPr id="17" name="Shape 15"/>
           <p:cNvSpPr/>
           <p:nvPr/>
         </p:nvSpPr>
@@ -14795,7 +14098,7 @@
       </p:sp>
       <p:sp>
         <p:nvSpPr>
-          <p:cNvPr id="19" name="Text 17"/>
+          <p:cNvPr id="18" name="Text 16"/>
           <p:cNvSpPr/>
           <p:nvPr/>
         </p:nvSpPr>
@@ -14836,7 +14139,7 @@
       </p:sp>
       <p:sp>
         <p:nvSpPr>
-          <p:cNvPr id="20" name="Shape 18"/>
+          <p:cNvPr id="19" name="Shape 17"/>
           <p:cNvSpPr/>
           <p:nvPr/>
         </p:nvSpPr>
@@ -14861,7 +14164,7 @@
       </p:sp>
       <p:sp>
         <p:nvSpPr>
-          <p:cNvPr id="21" name="Text 19"/>
+          <p:cNvPr id="20" name="Text 18"/>
           <p:cNvSpPr/>
           <p:nvPr/>
         </p:nvSpPr>
@@ -14902,7 +14205,7 @@
       </p:sp>
       <p:sp>
         <p:nvSpPr>
-          <p:cNvPr id="22" name="Shape 20"/>
+          <p:cNvPr id="21" name="Shape 19"/>
           <p:cNvSpPr/>
           <p:nvPr/>
         </p:nvSpPr>
@@ -14927,7 +14230,7 @@
       </p:sp>
       <p:sp>
         <p:nvSpPr>
-          <p:cNvPr id="23" name="Text 21"/>
+          <p:cNvPr id="22" name="Text 20"/>
           <p:cNvSpPr/>
           <p:nvPr/>
         </p:nvSpPr>
@@ -16055,17 +15358,17 @@
         </p:nvSpPr>
         <p:spPr>
           <a:xfrm>
-            <a:off x="612648" y="822960"/>
-            <a:ext cx="7498080" cy="228600"/>
-          </a:xfrm>
-          <a:prstGeom prst="rect">
-            <a:avLst/>
-          </a:prstGeom>
-          <a:noFill/>
-          <a:ln/>
-        </p:spPr>
-        <p:txBody>
-          <a:bodyPr wrap="square" lIns="0" tIns="0" rIns="0" bIns="0" rtlCol="0" anchor="ctr">
+            <a:off x="713232" y="1115568"/>
+            <a:ext cx="7498080" cy="274320"/>
+          </a:xfrm>
+          <a:prstGeom prst="rect">
+            <a:avLst/>
+          </a:prstGeom>
+          <a:noFill/>
+          <a:ln/>
+        </p:spPr>
+        <p:txBody>
+          <a:bodyPr wrap="square" lIns="254" tIns="254" rIns="254" bIns="254" rtlCol="0" anchor="t">
             <a:normAutofit/>
           </a:bodyPr>
           <a:lstStyle/>
@@ -16074,55 +15377,14 @@
               <a:buNone/>
             </a:pPr>
             <a:r>
-              <a:rPr lang="en-US" sz="1150" dirty="0">
-                <a:solidFill>
-                  <a:srgbClr val="606B78"/>
+              <a:rPr lang="en-US" sz="1550" b="1" dirty="0">
+                <a:solidFill>
+                  <a:srgbClr val="0F766E"/>
                 </a:solidFill>
                 <a:latin typeface="Malgun Gothic" pitchFamily="34" charset="0"/>
                 <a:ea typeface="Malgun Gothic" pitchFamily="34" charset="-122"/>
                 <a:cs typeface="Malgun Gothic" pitchFamily="34" charset="-120"/>
               </a:rPr>
-              <a:t>간단한 UI 행동에 적합하다</a:t>
-            </a:r>
-            <a:endParaRPr lang="en-US" sz="1150" dirty="0"/>
-          </a:p>
-        </p:txBody>
-      </p:sp>
-      <p:sp>
-        <p:nvSpPr>
-          <p:cNvPr id="8" name="Text 6"/>
-          <p:cNvSpPr/>
-          <p:nvPr/>
-        </p:nvSpPr>
-        <p:spPr>
-          <a:xfrm>
-            <a:off x="713232" y="1115568"/>
-            <a:ext cx="7498080" cy="274320"/>
-          </a:xfrm>
-          <a:prstGeom prst="rect">
-            <a:avLst/>
-          </a:prstGeom>
-          <a:noFill/>
-          <a:ln/>
-        </p:spPr>
-        <p:txBody>
-          <a:bodyPr wrap="square" lIns="254" tIns="254" rIns="254" bIns="254" rtlCol="0" anchor="t">
-            <a:normAutofit/>
-          </a:bodyPr>
-          <a:lstStyle/>
-          <a:p>
-            <a:pPr indent="0" marL="0">
-              <a:buNone/>
-            </a:pPr>
-            <a:r>
-              <a:rPr lang="en-US" sz="1550" b="1" dirty="0">
-                <a:solidFill>
-                  <a:srgbClr val="0F766E"/>
-                </a:solidFill>
-                <a:latin typeface="Malgun Gothic" pitchFamily="34" charset="0"/>
-                <a:ea typeface="Malgun Gothic" pitchFamily="34" charset="-122"/>
-                <a:cs typeface="Malgun Gothic" pitchFamily="34" charset="-120"/>
-              </a:rPr>
               <a:t>함수를 객체로 감싸는 얇은 어댑터다.</a:t>
             </a:r>
             <a:endParaRPr lang="en-US" sz="1550" dirty="0"/>
@@ -16131,7 +15393,7 @@
       </p:sp>
       <p:sp>
         <p:nvSpPr>
-          <p:cNvPr id="9" name="Shape 7"/>
+          <p:cNvPr id="8" name="Shape 6"/>
           <p:cNvSpPr/>
           <p:nvPr/>
         </p:nvSpPr>
@@ -16160,7 +15422,7 @@
       </p:sp>
       <p:sp>
         <p:nvSpPr>
-          <p:cNvPr id="10" name="Text 8"/>
+          <p:cNvPr id="9" name="Text 7"/>
           <p:cNvSpPr/>
           <p:nvPr/>
         </p:nvSpPr>
@@ -16550,48 +15812,7 @@
       </p:sp>
       <p:sp>
         <p:nvSpPr>
-          <p:cNvPr id="7" name="Text 5"/>
-          <p:cNvSpPr/>
-          <p:nvPr/>
-        </p:nvSpPr>
-        <p:spPr>
-          <a:xfrm>
-            <a:off x="612648" y="822960"/>
-            <a:ext cx="7498080" cy="228600"/>
-          </a:xfrm>
-          <a:prstGeom prst="rect">
-            <a:avLst/>
-          </a:prstGeom>
-          <a:noFill/>
-          <a:ln/>
-        </p:spPr>
-        <p:txBody>
-          <a:bodyPr wrap="square" lIns="0" tIns="0" rIns="0" bIns="0" rtlCol="0" anchor="ctr">
-            <a:normAutofit/>
-          </a:bodyPr>
-          <a:lstStyle/>
-          <a:p>
-            <a:pPr indent="0" marL="0">
-              <a:buNone/>
-            </a:pPr>
-            <a:r>
-              <a:rPr lang="en-US" sz="1150" dirty="0">
-                <a:solidFill>
-                  <a:srgbClr val="606B78"/>
-                </a:solidFill>
-                <a:latin typeface="Malgun Gothic" pitchFamily="34" charset="0"/>
-                <a:ea typeface="Malgun Gothic" pitchFamily="34" charset="-122"/>
-                <a:cs typeface="Malgun Gothic" pitchFamily="34" charset="-120"/>
-              </a:rPr>
-              <a:t>책 내용을 빼지 않고 수업 순서로 재배치</a:t>
-            </a:r>
-            <a:endParaRPr lang="en-US" sz="1150" dirty="0"/>
-          </a:p>
-        </p:txBody>
-      </p:sp>
-      <p:sp>
-        <p:nvSpPr>
-          <p:cNvPr id="8" name="Shape 6"/>
+          <p:cNvPr id="7" name="Shape 5"/>
           <p:cNvSpPr/>
           <p:nvPr/>
         </p:nvSpPr>
@@ -16616,7 +15837,7 @@
       </p:sp>
       <p:sp>
         <p:nvSpPr>
-          <p:cNvPr id="9" name="Text 7"/>
+          <p:cNvPr id="8" name="Text 6"/>
           <p:cNvSpPr/>
           <p:nvPr/>
         </p:nvSpPr>
@@ -16657,7 +15878,7 @@
       </p:sp>
       <p:sp>
         <p:nvSpPr>
-          <p:cNvPr id="10" name="Shape 8"/>
+          <p:cNvPr id="9" name="Shape 7"/>
           <p:cNvSpPr/>
           <p:nvPr/>
         </p:nvSpPr>
@@ -16682,7 +15903,7 @@
       </p:sp>
       <p:sp>
         <p:nvSpPr>
-          <p:cNvPr id="11" name="Text 9"/>
+          <p:cNvPr id="10" name="Text 8"/>
           <p:cNvSpPr/>
           <p:nvPr/>
         </p:nvSpPr>
@@ -16723,7 +15944,7 @@
       </p:sp>
       <p:sp>
         <p:nvSpPr>
-          <p:cNvPr id="12" name="Shape 10"/>
+          <p:cNvPr id="11" name="Shape 9"/>
           <p:cNvSpPr/>
           <p:nvPr/>
         </p:nvSpPr>
@@ -16748,7 +15969,7 @@
       </p:sp>
       <p:sp>
         <p:nvSpPr>
-          <p:cNvPr id="13" name="Text 11"/>
+          <p:cNvPr id="12" name="Text 10"/>
           <p:cNvSpPr/>
           <p:nvPr/>
         </p:nvSpPr>
@@ -16789,7 +16010,7 @@
       </p:sp>
       <p:sp>
         <p:nvSpPr>
-          <p:cNvPr id="14" name="Shape 12"/>
+          <p:cNvPr id="13" name="Shape 11"/>
           <p:cNvSpPr/>
           <p:nvPr/>
         </p:nvSpPr>
@@ -16814,7 +16035,7 @@
       </p:sp>
       <p:sp>
         <p:nvSpPr>
-          <p:cNvPr id="15" name="Text 13"/>
+          <p:cNvPr id="14" name="Text 12"/>
           <p:cNvSpPr/>
           <p:nvPr/>
         </p:nvSpPr>
@@ -17056,48 +16277,7 @@
       </p:sp>
       <p:sp>
         <p:nvSpPr>
-          <p:cNvPr id="7" name="Text 5"/>
-          <p:cNvSpPr/>
-          <p:nvPr/>
-        </p:nvSpPr>
-        <p:spPr>
-          <a:xfrm>
-            <a:off x="612648" y="822960"/>
-            <a:ext cx="7498080" cy="228600"/>
-          </a:xfrm>
-          <a:prstGeom prst="rect">
-            <a:avLst/>
-          </a:prstGeom>
-          <a:noFill/>
-          <a:ln/>
-        </p:spPr>
-        <p:txBody>
-          <a:bodyPr wrap="square" lIns="0" tIns="0" rIns="0" bIns="0" rtlCol="0" anchor="ctr">
-            <a:normAutofit/>
-          </a:bodyPr>
-          <a:lstStyle/>
-          <a:p>
-            <a:pPr indent="0" marL="0">
-              <a:buNone/>
-            </a:pPr>
-            <a:r>
-              <a:rPr lang="en-US" sz="1150" dirty="0">
-                <a:solidFill>
-                  <a:srgbClr val="606B78"/>
-                </a:solidFill>
-                <a:latin typeface="Malgun Gothic" pitchFamily="34" charset="0"/>
-                <a:ea typeface="Malgun Gothic" pitchFamily="34" charset="-122"/>
-                <a:cs typeface="Malgun Gothic" pitchFamily="34" charset="-120"/>
-              </a:rPr>
-              <a:t>원문 See Also 정리</a:t>
-            </a:r>
-            <a:endParaRPr lang="en-US" sz="1150" dirty="0"/>
-          </a:p>
-        </p:txBody>
-      </p:sp>
-      <p:sp>
-        <p:nvSpPr>
-          <p:cNvPr id="8" name="Shape 6"/>
+          <p:cNvPr id="7" name="Shape 5"/>
           <p:cNvSpPr/>
           <p:nvPr/>
         </p:nvSpPr>
@@ -17122,7 +16302,7 @@
       </p:sp>
       <p:sp>
         <p:nvSpPr>
-          <p:cNvPr id="9" name="Text 7"/>
+          <p:cNvPr id="8" name="Text 6"/>
           <p:cNvSpPr/>
           <p:nvPr/>
         </p:nvSpPr>
@@ -17163,7 +16343,7 @@
       </p:sp>
       <p:sp>
         <p:nvSpPr>
-          <p:cNvPr id="10" name="Shape 8"/>
+          <p:cNvPr id="9" name="Shape 7"/>
           <p:cNvSpPr/>
           <p:nvPr/>
         </p:nvSpPr>
@@ -17188,7 +16368,7 @@
       </p:sp>
       <p:sp>
         <p:nvSpPr>
-          <p:cNvPr id="11" name="Text 9"/>
+          <p:cNvPr id="10" name="Text 8"/>
           <p:cNvSpPr/>
           <p:nvPr/>
         </p:nvSpPr>
@@ -17229,7 +16409,7 @@
       </p:sp>
       <p:sp>
         <p:nvSpPr>
-          <p:cNvPr id="12" name="Shape 10"/>
+          <p:cNvPr id="11" name="Shape 9"/>
           <p:cNvSpPr/>
           <p:nvPr/>
         </p:nvSpPr>
@@ -17254,7 +16434,7 @@
       </p:sp>
       <p:sp>
         <p:nvSpPr>
-          <p:cNvPr id="13" name="Text 11"/>
+          <p:cNvPr id="12" name="Text 10"/>
           <p:cNvSpPr/>
           <p:nvPr/>
         </p:nvSpPr>
@@ -17496,48 +16676,7 @@
       </p:sp>
       <p:sp>
         <p:nvSpPr>
-          <p:cNvPr id="7" name="Text 5"/>
-          <p:cNvSpPr/>
-          <p:nvPr/>
-        </p:nvSpPr>
-        <p:spPr>
-          <a:xfrm>
-            <a:off x="612648" y="822960"/>
-            <a:ext cx="7498080" cy="228600"/>
-          </a:xfrm>
-          <a:prstGeom prst="rect">
-            <a:avLst/>
-          </a:prstGeom>
-          <a:noFill/>
-          <a:ln/>
-        </p:spPr>
-        <p:txBody>
-          <a:bodyPr wrap="square" lIns="0" tIns="0" rIns="0" bIns="0" rtlCol="0" anchor="ctr">
-            <a:normAutofit/>
-          </a:bodyPr>
-          <a:lstStyle/>
-          <a:p>
-            <a:pPr indent="0" marL="0">
-              <a:buNone/>
-            </a:pPr>
-            <a:r>
-              <a:rPr lang="en-US" sz="1150" dirty="0">
-                <a:solidFill>
-                  <a:srgbClr val="606B78"/>
-                </a:solidFill>
-                <a:latin typeface="Malgun Gothic" pitchFamily="34" charset="0"/>
-                <a:ea typeface="Malgun Gothic" pitchFamily="34" charset="-122"/>
-                <a:cs typeface="Malgun Gothic" pitchFamily="34" charset="-120"/>
-              </a:rPr>
-              <a:t>패턴은 필요할 때만 꺼낸다</a:t>
-            </a:r>
-            <a:endParaRPr lang="en-US" sz="1150" dirty="0"/>
-          </a:p>
-        </p:txBody>
-      </p:sp>
-      <p:sp>
-        <p:nvSpPr>
-          <p:cNvPr id="8" name="Shape 6"/>
+          <p:cNvPr id="7" name="Shape 5"/>
           <p:cNvSpPr/>
           <p:nvPr/>
         </p:nvSpPr>
@@ -17562,7 +16701,7 @@
       </p:sp>
       <p:sp>
         <p:nvSpPr>
-          <p:cNvPr id="9" name="Text 7"/>
+          <p:cNvPr id="8" name="Text 6"/>
           <p:cNvSpPr/>
           <p:nvPr/>
         </p:nvSpPr>
@@ -17603,7 +16742,7 @@
       </p:sp>
       <p:sp>
         <p:nvSpPr>
-          <p:cNvPr id="10" name="Shape 8"/>
+          <p:cNvPr id="9" name="Shape 7"/>
           <p:cNvSpPr/>
           <p:nvPr/>
         </p:nvSpPr>
@@ -17628,7 +16767,7 @@
       </p:sp>
       <p:sp>
         <p:nvSpPr>
-          <p:cNvPr id="11" name="Text 9"/>
+          <p:cNvPr id="10" name="Text 8"/>
           <p:cNvSpPr/>
           <p:nvPr/>
         </p:nvSpPr>
@@ -17669,7 +16808,7 @@
       </p:sp>
       <p:sp>
         <p:nvSpPr>
-          <p:cNvPr id="12" name="Shape 10"/>
+          <p:cNvPr id="11" name="Shape 9"/>
           <p:cNvSpPr/>
           <p:nvPr/>
         </p:nvSpPr>
@@ -17694,7 +16833,7 @@
       </p:sp>
       <p:sp>
         <p:nvSpPr>
-          <p:cNvPr id="13" name="Text 11"/>
+          <p:cNvPr id="12" name="Text 10"/>
           <p:cNvSpPr/>
           <p:nvPr/>
         </p:nvSpPr>
@@ -17735,7 +16874,7 @@
       </p:sp>
       <p:sp>
         <p:nvSpPr>
-          <p:cNvPr id="14" name="Shape 12"/>
+          <p:cNvPr id="13" name="Shape 11"/>
           <p:cNvSpPr/>
           <p:nvPr/>
         </p:nvSpPr>
@@ -17760,7 +16899,7 @@
       </p:sp>
       <p:sp>
         <p:nvSpPr>
-          <p:cNvPr id="15" name="Text 13"/>
+          <p:cNvPr id="14" name="Text 12"/>
           <p:cNvSpPr/>
           <p:nvPr/>
         </p:nvSpPr>
@@ -18002,48 +17141,7 @@
       </p:sp>
       <p:sp>
         <p:nvSpPr>
-          <p:cNvPr id="7" name="Text 5"/>
-          <p:cNvSpPr/>
-          <p:nvPr/>
-        </p:nvSpPr>
-        <p:spPr>
-          <a:xfrm>
-            <a:off x="612648" y="822960"/>
-            <a:ext cx="7498080" cy="228600"/>
-          </a:xfrm>
-          <a:prstGeom prst="rect">
-            <a:avLst/>
-          </a:prstGeom>
-          <a:noFill/>
-          <a:ln/>
-        </p:spPr>
-        <p:txBody>
-          <a:bodyPr wrap="square" lIns="0" tIns="0" rIns="0" bIns="0" rtlCol="0" anchor="ctr">
-            <a:normAutofit/>
-          </a:bodyPr>
-          <a:lstStyle/>
-          <a:p>
-            <a:pPr indent="0" marL="0">
-              <a:buNone/>
-            </a:pPr>
-            <a:r>
-              <a:rPr lang="en-US" sz="1150" dirty="0">
-                <a:solidFill>
-                  <a:srgbClr val="606B78"/>
-                </a:solidFill>
-                <a:latin typeface="Malgun Gothic" pitchFamily="34" charset="0"/>
-                <a:ea typeface="Malgun Gothic" pitchFamily="34" charset="-122"/>
-                <a:cs typeface="Malgun Gothic" pitchFamily="34" charset="-120"/>
-              </a:rPr>
-              <a:t>결합은 줄지만 규칙과 파일은 늘어난다</a:t>
-            </a:r>
-            <a:endParaRPr lang="en-US" sz="1150" dirty="0"/>
-          </a:p>
-        </p:txBody>
-      </p:sp>
-      <p:sp>
-        <p:nvSpPr>
-          <p:cNvPr id="8" name="Shape 6"/>
+          <p:cNvPr id="7" name="Shape 5"/>
           <p:cNvSpPr/>
           <p:nvPr/>
         </p:nvSpPr>
@@ -18068,7 +17166,7 @@
       </p:sp>
       <p:sp>
         <p:nvSpPr>
-          <p:cNvPr id="9" name="Text 7"/>
+          <p:cNvPr id="8" name="Text 6"/>
           <p:cNvSpPr/>
           <p:nvPr/>
         </p:nvSpPr>
@@ -18109,7 +17207,7 @@
       </p:sp>
       <p:sp>
         <p:nvSpPr>
-          <p:cNvPr id="10" name="Shape 8"/>
+          <p:cNvPr id="9" name="Shape 7"/>
           <p:cNvSpPr/>
           <p:nvPr/>
         </p:nvSpPr>
@@ -18134,7 +17232,7 @@
       </p:sp>
       <p:sp>
         <p:nvSpPr>
-          <p:cNvPr id="11" name="Text 9"/>
+          <p:cNvPr id="10" name="Text 8"/>
           <p:cNvSpPr/>
           <p:nvPr/>
         </p:nvSpPr>
@@ -18175,7 +17273,7 @@
       </p:sp>
       <p:sp>
         <p:nvSpPr>
-          <p:cNvPr id="12" name="Shape 10"/>
+          <p:cNvPr id="11" name="Shape 9"/>
           <p:cNvSpPr/>
           <p:nvPr/>
         </p:nvSpPr>
@@ -18200,7 +17298,7 @@
       </p:sp>
       <p:sp>
         <p:nvSpPr>
-          <p:cNvPr id="13" name="Text 11"/>
+          <p:cNvPr id="12" name="Text 10"/>
           <p:cNvSpPr/>
           <p:nvPr/>
         </p:nvSpPr>
@@ -18241,7 +17339,7 @@
       </p:sp>
       <p:sp>
         <p:nvSpPr>
-          <p:cNvPr id="14" name="Shape 12"/>
+          <p:cNvPr id="13" name="Shape 11"/>
           <p:cNvSpPr/>
           <p:nvPr/>
         </p:nvSpPr>
@@ -18266,7 +17364,7 @@
       </p:sp>
       <p:sp>
         <p:nvSpPr>
-          <p:cNvPr id="15" name="Text 13"/>
+          <p:cNvPr id="14" name="Text 12"/>
           <p:cNvSpPr/>
           <p:nvPr/>
         </p:nvSpPr>
@@ -18514,17 +17612,17 @@
         </p:nvSpPr>
         <p:spPr>
           <a:xfrm>
-            <a:off x="612648" y="822960"/>
-            <a:ext cx="7498080" cy="228600"/>
-          </a:xfrm>
-          <a:prstGeom prst="rect">
-            <a:avLst/>
-          </a:prstGeom>
-          <a:noFill/>
-          <a:ln/>
-        </p:spPr>
-        <p:txBody>
-          <a:bodyPr wrap="square" lIns="0" tIns="0" rIns="0" bIns="0" rtlCol="0" anchor="ctr">
+            <a:off x="749808" y="1335024"/>
+            <a:ext cx="7498080" cy="512064"/>
+          </a:xfrm>
+          <a:prstGeom prst="rect">
+            <a:avLst/>
+          </a:prstGeom>
+          <a:noFill/>
+          <a:ln/>
+        </p:spPr>
+        <p:txBody>
+          <a:bodyPr wrap="square" lIns="254" tIns="254" rIns="254" bIns="254" rtlCol="0" anchor="t">
             <a:normAutofit/>
           </a:bodyPr>
           <a:lstStyle/>
@@ -18533,55 +17631,14 @@
               <a:buNone/>
             </a:pPr>
             <a:r>
-              <a:rPr lang="en-US" sz="1150" dirty="0">
-                <a:solidFill>
-                  <a:srgbClr val="606B78"/>
+              <a:rPr lang="en-US" sz="1840" b="1" dirty="0">
+                <a:solidFill>
+                  <a:srgbClr val="17212B"/>
                 </a:solidFill>
                 <a:latin typeface="Malgun Gothic" pitchFamily="34" charset="0"/>
                 <a:ea typeface="Malgun Gothic" pitchFamily="34" charset="-122"/>
                 <a:cs typeface="Malgun Gothic" pitchFamily="34" charset="-120"/>
               </a:rPr>
-              <a:t>격자 이동 게임으로 패턴을 완성한다</a:t>
-            </a:r>
-            <a:endParaRPr lang="en-US" sz="1150" dirty="0"/>
-          </a:p>
-        </p:txBody>
-      </p:sp>
-      <p:sp>
-        <p:nvSpPr>
-          <p:cNvPr id="8" name="Text 6"/>
-          <p:cNvSpPr/>
-          <p:nvPr/>
-        </p:nvSpPr>
-        <p:spPr>
-          <a:xfrm>
-            <a:off x="749808" y="1335024"/>
-            <a:ext cx="7498080" cy="512064"/>
-          </a:xfrm>
-          <a:prstGeom prst="rect">
-            <a:avLst/>
-          </a:prstGeom>
-          <a:noFill/>
-          <a:ln/>
-        </p:spPr>
-        <p:txBody>
-          <a:bodyPr wrap="square" lIns="254" tIns="254" rIns="254" bIns="254" rtlCol="0" anchor="t">
-            <a:normAutofit/>
-          </a:bodyPr>
-          <a:lstStyle/>
-          <a:p>
-            <a:pPr indent="0" marL="0">
-              <a:buNone/>
-            </a:pPr>
-            <a:r>
-              <a:rPr lang="en-US" sz="1840" b="1" dirty="0">
-                <a:solidFill>
-                  <a:srgbClr val="17212B"/>
-                </a:solidFill>
-                <a:latin typeface="Malgun Gothic" pitchFamily="34" charset="0"/>
-                <a:ea typeface="Malgun Gothic" pitchFamily="34" charset="-122"/>
-                <a:cs typeface="Malgun Gothic" pitchFamily="34" charset="-120"/>
-              </a:rPr>
               <a:t>방향키는 이동 명령을 만들고, Z/Y는 Undo/Redo를 호출한다.</a:t>
             </a:r>
             <a:endParaRPr lang="en-US" sz="1840" dirty="0"/>
@@ -18590,7 +17647,7 @@
       </p:sp>
       <p:sp>
         <p:nvSpPr>
-          <p:cNvPr id="9" name="Shape 7"/>
+          <p:cNvPr id="8" name="Shape 6"/>
           <p:cNvSpPr/>
           <p:nvPr/>
         </p:nvSpPr>
@@ -18617,7 +17674,7 @@
       </p:sp>
       <p:sp>
         <p:nvSpPr>
-          <p:cNvPr id="10" name="Text 8"/>
+          <p:cNvPr id="9" name="Text 7"/>
           <p:cNvSpPr/>
           <p:nvPr/>
         </p:nvSpPr>
@@ -18658,7 +17715,7 @@
       </p:sp>
       <p:sp>
         <p:nvSpPr>
-          <p:cNvPr id="11" name="Text 9"/>
+          <p:cNvPr id="10" name="Text 8"/>
           <p:cNvSpPr/>
           <p:nvPr/>
         </p:nvSpPr>
@@ -18694,7 +17751,7 @@
       </p:sp>
       <p:sp>
         <p:nvSpPr>
-          <p:cNvPr id="12" name="Shape 10"/>
+          <p:cNvPr id="11" name="Shape 9"/>
           <p:cNvSpPr/>
           <p:nvPr/>
         </p:nvSpPr>
@@ -18721,7 +17778,7 @@
       </p:sp>
       <p:sp>
         <p:nvSpPr>
-          <p:cNvPr id="13" name="Text 11"/>
+          <p:cNvPr id="12" name="Text 10"/>
           <p:cNvSpPr/>
           <p:nvPr/>
         </p:nvSpPr>
@@ -18762,7 +17819,7 @@
       </p:sp>
       <p:sp>
         <p:nvSpPr>
-          <p:cNvPr id="14" name="Text 12"/>
+          <p:cNvPr id="13" name="Text 11"/>
           <p:cNvSpPr/>
           <p:nvPr/>
         </p:nvSpPr>
@@ -18798,7 +17855,7 @@
       </p:sp>
       <p:sp>
         <p:nvSpPr>
-          <p:cNvPr id="15" name="Shape 13"/>
+          <p:cNvPr id="14" name="Shape 12"/>
           <p:cNvSpPr/>
           <p:nvPr/>
         </p:nvSpPr>
@@ -18825,7 +17882,7 @@
       </p:sp>
       <p:sp>
         <p:nvSpPr>
-          <p:cNvPr id="16" name="Text 14"/>
+          <p:cNvPr id="15" name="Text 13"/>
           <p:cNvSpPr/>
           <p:nvPr/>
         </p:nvSpPr>
@@ -18866,7 +17923,7 @@
       </p:sp>
       <p:sp>
         <p:nvSpPr>
-          <p:cNvPr id="17" name="Text 15"/>
+          <p:cNvPr id="16" name="Text 14"/>
           <p:cNvSpPr/>
           <p:nvPr/>
         </p:nvSpPr>
@@ -18902,7 +17959,7 @@
       </p:sp>
       <p:sp>
         <p:nvSpPr>
-          <p:cNvPr id="18" name="Shape 16"/>
+          <p:cNvPr id="17" name="Shape 15"/>
           <p:cNvSpPr/>
           <p:nvPr/>
         </p:nvSpPr>
@@ -18929,7 +17986,7 @@
       </p:sp>
       <p:sp>
         <p:nvSpPr>
-          <p:cNvPr id="19" name="Text 17"/>
+          <p:cNvPr id="18" name="Text 16"/>
           <p:cNvSpPr/>
           <p:nvPr/>
         </p:nvSpPr>
@@ -18970,7 +18027,7 @@
       </p:sp>
       <p:sp>
         <p:nvSpPr>
-          <p:cNvPr id="20" name="Shape 18"/>
+          <p:cNvPr id="19" name="Shape 17"/>
           <p:cNvSpPr/>
           <p:nvPr/>
         </p:nvSpPr>
@@ -18995,7 +18052,7 @@
       </p:sp>
       <p:sp>
         <p:nvSpPr>
-          <p:cNvPr id="21" name="Text 19"/>
+          <p:cNvPr id="20" name="Text 18"/>
           <p:cNvSpPr/>
           <p:nvPr/>
         </p:nvSpPr>
@@ -19036,7 +18093,7 @@
       </p:sp>
       <p:sp>
         <p:nvSpPr>
-          <p:cNvPr id="22" name="Shape 20"/>
+          <p:cNvPr id="21" name="Shape 19"/>
           <p:cNvSpPr/>
           <p:nvPr/>
         </p:nvSpPr>
@@ -19061,7 +18118,7 @@
       </p:sp>
       <p:sp>
         <p:nvSpPr>
-          <p:cNvPr id="23" name="Text 21"/>
+          <p:cNvPr id="22" name="Text 20"/>
           <p:cNvSpPr/>
           <p:nvPr/>
         </p:nvSpPr>
@@ -19303,48 +18360,7 @@
       </p:sp>
       <p:sp>
         <p:nvSpPr>
-          <p:cNvPr id="7" name="Text 5"/>
-          <p:cNvSpPr/>
-          <p:nvPr/>
-        </p:nvSpPr>
-        <p:spPr>
-          <a:xfrm>
-            <a:off x="612648" y="822960"/>
-            <a:ext cx="7498080" cy="228600"/>
-          </a:xfrm>
-          <a:prstGeom prst="rect">
-            <a:avLst/>
-          </a:prstGeom>
-          <a:noFill/>
-          <a:ln/>
-        </p:spPr>
-        <p:txBody>
-          <a:bodyPr wrap="square" lIns="0" tIns="0" rIns="0" bIns="0" rtlCol="0" anchor="ctr">
-            <a:normAutofit/>
-          </a:bodyPr>
-          <a:lstStyle/>
-          <a:p>
-            <a:pPr indent="0" marL="0">
-              <a:buNone/>
-            </a:pPr>
-            <a:r>
-              <a:rPr lang="en-US" sz="1150" dirty="0">
-                <a:solidFill>
-                  <a:srgbClr val="606B78"/>
-                </a:solidFill>
-                <a:latin typeface="Malgun Gothic" pitchFamily="34" charset="0"/>
-                <a:ea typeface="Malgun Gothic" pitchFamily="34" charset="-122"/>
-                <a:cs typeface="Malgun Gothic" pitchFamily="34" charset="-120"/>
-              </a:rPr>
-              <a:t>Git으로 받은 Unity 프로젝트에서 완성하기</a:t>
-            </a:r>
-            <a:endParaRPr lang="en-US" sz="1150" dirty="0"/>
-          </a:p>
-        </p:txBody>
-      </p:sp>
-      <p:sp>
-        <p:nvSpPr>
-          <p:cNvPr id="8" name="Shape 6"/>
+          <p:cNvPr id="7" name="Shape 5"/>
           <p:cNvSpPr/>
           <p:nvPr/>
         </p:nvSpPr>
@@ -19371,7 +18387,7 @@
       </p:sp>
       <p:sp>
         <p:nvSpPr>
-          <p:cNvPr id="9" name="Text 7"/>
+          <p:cNvPr id="8" name="Text 6"/>
           <p:cNvSpPr/>
           <p:nvPr/>
         </p:nvSpPr>
@@ -19407,7 +18423,7 @@
       </p:sp>
       <p:sp>
         <p:nvSpPr>
-          <p:cNvPr id="10" name="Shape 8"/>
+          <p:cNvPr id="9" name="Shape 7"/>
           <p:cNvSpPr/>
           <p:nvPr/>
         </p:nvSpPr>
@@ -19432,7 +18448,7 @@
       </p:sp>
       <p:sp>
         <p:nvSpPr>
-          <p:cNvPr id="11" name="Text 9"/>
+          <p:cNvPr id="10" name="Text 8"/>
           <p:cNvSpPr/>
           <p:nvPr/>
         </p:nvSpPr>
@@ -19473,7 +18489,7 @@
       </p:sp>
       <p:sp>
         <p:nvSpPr>
-          <p:cNvPr id="12" name="Shape 10"/>
+          <p:cNvPr id="11" name="Shape 9"/>
           <p:cNvSpPr/>
           <p:nvPr/>
         </p:nvSpPr>
@@ -19498,7 +18514,7 @@
       </p:sp>
       <p:sp>
         <p:nvSpPr>
-          <p:cNvPr id="13" name="Text 11"/>
+          <p:cNvPr id="12" name="Text 10"/>
           <p:cNvSpPr/>
           <p:nvPr/>
         </p:nvSpPr>
@@ -19539,7 +18555,7 @@
       </p:sp>
       <p:sp>
         <p:nvSpPr>
-          <p:cNvPr id="14" name="Shape 12"/>
+          <p:cNvPr id="13" name="Shape 11"/>
           <p:cNvSpPr/>
           <p:nvPr/>
         </p:nvSpPr>
@@ -19564,7 +18580,7 @@
       </p:sp>
       <p:sp>
         <p:nvSpPr>
-          <p:cNvPr id="15" name="Text 13"/>
+          <p:cNvPr id="14" name="Text 12"/>
           <p:cNvSpPr/>
           <p:nvPr/>
         </p:nvSpPr>
@@ -19605,7 +18621,7 @@
       </p:sp>
       <p:sp>
         <p:nvSpPr>
-          <p:cNvPr id="16" name="Shape 14"/>
+          <p:cNvPr id="15" name="Shape 13"/>
           <p:cNvSpPr/>
           <p:nvPr/>
         </p:nvSpPr>
@@ -19630,7 +18646,7 @@
       </p:sp>
       <p:sp>
         <p:nvSpPr>
-          <p:cNvPr id="17" name="Text 15"/>
+          <p:cNvPr id="16" name="Text 14"/>
           <p:cNvSpPr/>
           <p:nvPr/>
         </p:nvSpPr>
@@ -19872,48 +18888,7 @@
       </p:sp>
       <p:sp>
         <p:nvSpPr>
-          <p:cNvPr id="7" name="Text 5"/>
-          <p:cNvSpPr/>
-          <p:nvPr/>
-        </p:nvSpPr>
-        <p:spPr>
-          <a:xfrm>
-            <a:off x="612648" y="822960"/>
-            <a:ext cx="7498080" cy="228600"/>
-          </a:xfrm>
-          <a:prstGeom prst="rect">
-            <a:avLst/>
-          </a:prstGeom>
-          <a:noFill/>
-          <a:ln/>
-        </p:spPr>
-        <p:txBody>
-          <a:bodyPr wrap="square" lIns="0" tIns="0" rIns="0" bIns="0" rtlCol="0" anchor="ctr">
-            <a:normAutofit/>
-          </a:bodyPr>
-          <a:lstStyle/>
-          <a:p>
-            <a:pPr indent="0" marL="0">
-              <a:buNone/>
-            </a:pPr>
-            <a:r>
-              <a:rPr lang="en-US" sz="1150" dirty="0">
-                <a:solidFill>
-                  <a:srgbClr val="606B78"/>
-                </a:solidFill>
-                <a:latin typeface="Malgun Gothic" pitchFamily="34" charset="0"/>
-                <a:ea typeface="Malgun Gothic" pitchFamily="34" charset="-122"/>
-                <a:cs typeface="Malgun Gothic" pitchFamily="34" charset="-120"/>
-              </a:rPr>
-              <a:t>저장소에서 차시별 자료를 함께 받는다</a:t>
-            </a:r>
-            <a:endParaRPr lang="en-US" sz="1150" dirty="0"/>
-          </a:p>
-        </p:txBody>
-      </p:sp>
-      <p:sp>
-        <p:nvSpPr>
-          <p:cNvPr id="8" name="Shape 6"/>
+          <p:cNvPr id="7" name="Shape 5"/>
           <p:cNvSpPr/>
           <p:nvPr/>
         </p:nvSpPr>
@@ -19940,7 +18915,7 @@
       </p:sp>
       <p:sp>
         <p:nvSpPr>
-          <p:cNvPr id="9" name="Text 7"/>
+          <p:cNvPr id="8" name="Text 6"/>
           <p:cNvSpPr/>
           <p:nvPr/>
         </p:nvSpPr>
@@ -19976,7 +18951,7 @@
       </p:sp>
       <p:sp>
         <p:nvSpPr>
-          <p:cNvPr id="10" name="Shape 8"/>
+          <p:cNvPr id="9" name="Shape 7"/>
           <p:cNvSpPr/>
           <p:nvPr/>
         </p:nvSpPr>
@@ -20001,7 +18976,7 @@
       </p:sp>
       <p:sp>
         <p:nvSpPr>
-          <p:cNvPr id="11" name="Text 9"/>
+          <p:cNvPr id="10" name="Text 8"/>
           <p:cNvSpPr/>
           <p:nvPr/>
         </p:nvSpPr>
@@ -20042,7 +19017,7 @@
       </p:sp>
       <p:sp>
         <p:nvSpPr>
-          <p:cNvPr id="12" name="Shape 10"/>
+          <p:cNvPr id="11" name="Shape 9"/>
           <p:cNvSpPr/>
           <p:nvPr/>
         </p:nvSpPr>
@@ -20067,7 +19042,7 @@
       </p:sp>
       <p:sp>
         <p:nvSpPr>
-          <p:cNvPr id="13" name="Text 11"/>
+          <p:cNvPr id="12" name="Text 10"/>
           <p:cNvSpPr/>
           <p:nvPr/>
         </p:nvSpPr>
@@ -20108,7 +19083,7 @@
       </p:sp>
       <p:sp>
         <p:nvSpPr>
-          <p:cNvPr id="14" name="Shape 12"/>
+          <p:cNvPr id="13" name="Shape 11"/>
           <p:cNvSpPr/>
           <p:nvPr/>
         </p:nvSpPr>
@@ -20133,7 +19108,7 @@
       </p:sp>
       <p:sp>
         <p:nvSpPr>
-          <p:cNvPr id="15" name="Text 13"/>
+          <p:cNvPr id="14" name="Text 12"/>
           <p:cNvSpPr/>
           <p:nvPr/>
         </p:nvSpPr>
@@ -20174,7 +19149,7 @@
       </p:sp>
       <p:sp>
         <p:nvSpPr>
-          <p:cNvPr id="16" name="Shape 14"/>
+          <p:cNvPr id="15" name="Shape 13"/>
           <p:cNvSpPr/>
           <p:nvPr/>
         </p:nvSpPr>
@@ -20199,7 +19174,7 @@
       </p:sp>
       <p:sp>
         <p:nvSpPr>
-          <p:cNvPr id="17" name="Text 15"/>
+          <p:cNvPr id="16" name="Text 14"/>
           <p:cNvSpPr/>
           <p:nvPr/>
         </p:nvSpPr>
@@ -20441,48 +19416,7 @@
       </p:sp>
       <p:sp>
         <p:nvSpPr>
-          <p:cNvPr id="7" name="Text 5"/>
-          <p:cNvSpPr/>
-          <p:nvPr/>
-        </p:nvSpPr>
-        <p:spPr>
-          <a:xfrm>
-            <a:off x="612648" y="822960"/>
-            <a:ext cx="7498080" cy="228600"/>
-          </a:xfrm>
-          <a:prstGeom prst="rect">
-            <a:avLst/>
-          </a:prstGeom>
-          <a:noFill/>
-          <a:ln/>
-        </p:spPr>
-        <p:txBody>
-          <a:bodyPr wrap="square" lIns="0" tIns="0" rIns="0" bIns="0" rtlCol="0" anchor="ctr">
-            <a:normAutofit/>
-          </a:bodyPr>
-          <a:lstStyle/>
-          <a:p>
-            <a:pPr indent="0" marL="0">
-              <a:buNone/>
-            </a:pPr>
-            <a:r>
-              <a:rPr lang="en-US" sz="1150" dirty="0">
-                <a:solidFill>
-                  <a:srgbClr val="606B78"/>
-                </a:solidFill>
-                <a:latin typeface="Malgun Gothic" pitchFamily="34" charset="0"/>
-                <a:ea typeface="Malgun Gothic" pitchFamily="34" charset="-122"/>
-                <a:cs typeface="Malgun Gothic" pitchFamily="34" charset="-120"/>
-              </a:rPr>
-              <a:t>Command 객체 완성</a:t>
-            </a:r>
-            <a:endParaRPr lang="en-US" sz="1150" dirty="0"/>
-          </a:p>
-        </p:txBody>
-      </p:sp>
-      <p:sp>
-        <p:nvSpPr>
-          <p:cNvPr id="8" name="Shape 6"/>
+          <p:cNvPr id="7" name="Shape 5"/>
           <p:cNvSpPr/>
           <p:nvPr/>
         </p:nvSpPr>
@@ -20509,7 +19443,7 @@
       </p:sp>
       <p:sp>
         <p:nvSpPr>
-          <p:cNvPr id="9" name="Text 7"/>
+          <p:cNvPr id="8" name="Text 6"/>
           <p:cNvSpPr/>
           <p:nvPr/>
         </p:nvSpPr>
@@ -20545,7 +19479,7 @@
       </p:sp>
       <p:sp>
         <p:nvSpPr>
-          <p:cNvPr id="10" name="Shape 8"/>
+          <p:cNvPr id="9" name="Shape 7"/>
           <p:cNvSpPr/>
           <p:nvPr/>
         </p:nvSpPr>
@@ -20570,7 +19504,7 @@
       </p:sp>
       <p:sp>
         <p:nvSpPr>
-          <p:cNvPr id="11" name="Text 9"/>
+          <p:cNvPr id="10" name="Text 8"/>
           <p:cNvSpPr/>
           <p:nvPr/>
         </p:nvSpPr>
@@ -20611,7 +19545,7 @@
       </p:sp>
       <p:sp>
         <p:nvSpPr>
-          <p:cNvPr id="12" name="Shape 10"/>
+          <p:cNvPr id="11" name="Shape 9"/>
           <p:cNvSpPr/>
           <p:nvPr/>
         </p:nvSpPr>
@@ -20636,7 +19570,7 @@
       </p:sp>
       <p:sp>
         <p:nvSpPr>
-          <p:cNvPr id="13" name="Text 11"/>
+          <p:cNvPr id="12" name="Text 10"/>
           <p:cNvSpPr/>
           <p:nvPr/>
         </p:nvSpPr>
@@ -20677,7 +19611,7 @@
       </p:sp>
       <p:sp>
         <p:nvSpPr>
-          <p:cNvPr id="14" name="Shape 12"/>
+          <p:cNvPr id="13" name="Shape 11"/>
           <p:cNvSpPr/>
           <p:nvPr/>
         </p:nvSpPr>
@@ -20702,7 +19636,7 @@
       </p:sp>
       <p:sp>
         <p:nvSpPr>
-          <p:cNvPr id="15" name="Text 13"/>
+          <p:cNvPr id="14" name="Text 12"/>
           <p:cNvSpPr/>
           <p:nvPr/>
         </p:nvSpPr>
@@ -20743,7 +19677,7 @@
       </p:sp>
       <p:sp>
         <p:nvSpPr>
-          <p:cNvPr id="16" name="Shape 14"/>
+          <p:cNvPr id="15" name="Shape 13"/>
           <p:cNvSpPr/>
           <p:nvPr/>
         </p:nvSpPr>
@@ -20768,7 +19702,7 @@
       </p:sp>
       <p:sp>
         <p:nvSpPr>
-          <p:cNvPr id="17" name="Text 15"/>
+          <p:cNvPr id="16" name="Text 14"/>
           <p:cNvSpPr/>
           <p:nvPr/>
         </p:nvSpPr>
@@ -21010,48 +19944,7 @@
       </p:sp>
       <p:sp>
         <p:nvSpPr>
-          <p:cNvPr id="7" name="Text 5"/>
-          <p:cNvSpPr/>
-          <p:nvPr/>
-        </p:nvSpPr>
-        <p:spPr>
-          <a:xfrm>
-            <a:off x="612648" y="822960"/>
-            <a:ext cx="7498080" cy="228600"/>
-          </a:xfrm>
-          <a:prstGeom prst="rect">
-            <a:avLst/>
-          </a:prstGeom>
-          <a:noFill/>
-          <a:ln/>
-        </p:spPr>
-        <p:txBody>
-          <a:bodyPr wrap="square" lIns="0" tIns="0" rIns="0" bIns="0" rtlCol="0" anchor="ctr">
-            <a:normAutofit/>
-          </a:bodyPr>
-          <a:lstStyle/>
-          <a:p>
-            <a:pPr indent="0" marL="0">
-              <a:buNone/>
-            </a:pPr>
-            <a:r>
-              <a:rPr lang="en-US" sz="1150" dirty="0">
-                <a:solidFill>
-                  <a:srgbClr val="606B78"/>
-                </a:solidFill>
-                <a:latin typeface="Malgun Gothic" pitchFamily="34" charset="0"/>
-                <a:ea typeface="Malgun Gothic" pitchFamily="34" charset="-122"/>
-                <a:cs typeface="Malgun Gothic" pitchFamily="34" charset="-120"/>
-              </a:rPr>
-              <a:t>히스토리와 입력 연결</a:t>
-            </a:r>
-            <a:endParaRPr lang="en-US" sz="1150" dirty="0"/>
-          </a:p>
-        </p:txBody>
-      </p:sp>
-      <p:sp>
-        <p:nvSpPr>
-          <p:cNvPr id="8" name="Shape 6"/>
+          <p:cNvPr id="7" name="Shape 5"/>
           <p:cNvSpPr/>
           <p:nvPr/>
         </p:nvSpPr>
@@ -21078,7 +19971,7 @@
       </p:sp>
       <p:sp>
         <p:nvSpPr>
-          <p:cNvPr id="9" name="Text 7"/>
+          <p:cNvPr id="8" name="Text 6"/>
           <p:cNvSpPr/>
           <p:nvPr/>
         </p:nvSpPr>
@@ -21114,7 +20007,7 @@
       </p:sp>
       <p:sp>
         <p:nvSpPr>
-          <p:cNvPr id="10" name="Shape 8"/>
+          <p:cNvPr id="9" name="Shape 7"/>
           <p:cNvSpPr/>
           <p:nvPr/>
         </p:nvSpPr>
@@ -21139,7 +20032,7 @@
       </p:sp>
       <p:sp>
         <p:nvSpPr>
-          <p:cNvPr id="11" name="Text 9"/>
+          <p:cNvPr id="10" name="Text 8"/>
           <p:cNvSpPr/>
           <p:nvPr/>
         </p:nvSpPr>
@@ -21180,7 +20073,7 @@
       </p:sp>
       <p:sp>
         <p:nvSpPr>
-          <p:cNvPr id="12" name="Shape 10"/>
+          <p:cNvPr id="11" name="Shape 9"/>
           <p:cNvSpPr/>
           <p:nvPr/>
         </p:nvSpPr>
@@ -21205,7 +20098,7 @@
       </p:sp>
       <p:sp>
         <p:nvSpPr>
-          <p:cNvPr id="13" name="Text 11"/>
+          <p:cNvPr id="12" name="Text 10"/>
           <p:cNvSpPr/>
           <p:nvPr/>
         </p:nvSpPr>
@@ -21246,7 +20139,7 @@
       </p:sp>
       <p:sp>
         <p:nvSpPr>
-          <p:cNvPr id="14" name="Shape 12"/>
+          <p:cNvPr id="13" name="Shape 11"/>
           <p:cNvSpPr/>
           <p:nvPr/>
         </p:nvSpPr>
@@ -21271,7 +20164,7 @@
       </p:sp>
       <p:sp>
         <p:nvSpPr>
-          <p:cNvPr id="15" name="Text 13"/>
+          <p:cNvPr id="14" name="Text 12"/>
           <p:cNvSpPr/>
           <p:nvPr/>
         </p:nvSpPr>
@@ -21312,7 +20205,7 @@
       </p:sp>
       <p:sp>
         <p:nvSpPr>
-          <p:cNvPr id="16" name="Shape 14"/>
+          <p:cNvPr id="15" name="Shape 13"/>
           <p:cNvSpPr/>
           <p:nvPr/>
         </p:nvSpPr>
@@ -21337,7 +20230,7 @@
       </p:sp>
       <p:sp>
         <p:nvSpPr>
-          <p:cNvPr id="17" name="Text 15"/>
+          <p:cNvPr id="16" name="Text 14"/>
           <p:cNvSpPr/>
           <p:nvPr/>
         </p:nvSpPr>
@@ -21579,48 +20472,7 @@
       </p:sp>
       <p:sp>
         <p:nvSpPr>
-          <p:cNvPr id="7" name="Text 5"/>
-          <p:cNvSpPr/>
-          <p:nvPr/>
-        </p:nvSpPr>
-        <p:spPr>
-          <a:xfrm>
-            <a:off x="612648" y="822960"/>
-            <a:ext cx="7498080" cy="228600"/>
-          </a:xfrm>
-          <a:prstGeom prst="rect">
-            <a:avLst/>
-          </a:prstGeom>
-          <a:noFill/>
-          <a:ln/>
-        </p:spPr>
-        <p:txBody>
-          <a:bodyPr wrap="square" lIns="0" tIns="0" rIns="0" bIns="0" rtlCol="0" anchor="ctr">
-            <a:normAutofit/>
-          </a:bodyPr>
-          <a:lstStyle/>
-          <a:p>
-            <a:pPr indent="0" marL="0">
-              <a:buNone/>
-            </a:pPr>
-            <a:r>
-              <a:rPr lang="en-US" sz="1150" dirty="0">
-                <a:solidFill>
-                  <a:srgbClr val="606B78"/>
-                </a:solidFill>
-                <a:latin typeface="Malgun Gothic" pitchFamily="34" charset="0"/>
-                <a:ea typeface="Malgun Gothic" pitchFamily="34" charset="-122"/>
-                <a:cs typeface="Malgun Gothic" pitchFamily="34" charset="-120"/>
-              </a:rPr>
-              <a:t>기능보다 구조를 먼저 본다</a:t>
-            </a:r>
-            <a:endParaRPr lang="en-US" sz="1150" dirty="0"/>
-          </a:p>
-        </p:txBody>
-      </p:sp>
-      <p:sp>
-        <p:nvSpPr>
-          <p:cNvPr id="8" name="Shape 6"/>
+          <p:cNvPr id="7" name="Shape 5"/>
           <p:cNvSpPr/>
           <p:nvPr/>
         </p:nvSpPr>
@@ -21647,7 +20499,7 @@
       </p:sp>
       <p:sp>
         <p:nvSpPr>
-          <p:cNvPr id="9" name="Text 7"/>
+          <p:cNvPr id="8" name="Text 6"/>
           <p:cNvSpPr/>
           <p:nvPr/>
         </p:nvSpPr>
@@ -21683,7 +20535,7 @@
       </p:sp>
       <p:sp>
         <p:nvSpPr>
-          <p:cNvPr id="10" name="Shape 8"/>
+          <p:cNvPr id="9" name="Shape 7"/>
           <p:cNvSpPr/>
           <p:nvPr/>
         </p:nvSpPr>
@@ -21708,7 +20560,7 @@
       </p:sp>
       <p:sp>
         <p:nvSpPr>
-          <p:cNvPr id="11" name="Text 9"/>
+          <p:cNvPr id="10" name="Text 8"/>
           <p:cNvSpPr/>
           <p:nvPr/>
         </p:nvSpPr>
@@ -21749,7 +20601,7 @@
       </p:sp>
       <p:sp>
         <p:nvSpPr>
-          <p:cNvPr id="12" name="Shape 10"/>
+          <p:cNvPr id="11" name="Shape 9"/>
           <p:cNvSpPr/>
           <p:nvPr/>
         </p:nvSpPr>
@@ -21774,7 +20626,7 @@
       </p:sp>
       <p:sp>
         <p:nvSpPr>
-          <p:cNvPr id="13" name="Text 11"/>
+          <p:cNvPr id="12" name="Text 10"/>
           <p:cNvSpPr/>
           <p:nvPr/>
         </p:nvSpPr>
@@ -21815,7 +20667,7 @@
       </p:sp>
       <p:sp>
         <p:nvSpPr>
-          <p:cNvPr id="14" name="Shape 12"/>
+          <p:cNvPr id="13" name="Shape 11"/>
           <p:cNvSpPr/>
           <p:nvPr/>
         </p:nvSpPr>
@@ -21840,7 +20692,7 @@
       </p:sp>
       <p:sp>
         <p:nvSpPr>
-          <p:cNvPr id="15" name="Text 13"/>
+          <p:cNvPr id="14" name="Text 12"/>
           <p:cNvSpPr/>
           <p:nvPr/>
         </p:nvSpPr>
@@ -21881,7 +20733,7 @@
       </p:sp>
       <p:sp>
         <p:nvSpPr>
-          <p:cNvPr id="16" name="Shape 14"/>
+          <p:cNvPr id="15" name="Shape 13"/>
           <p:cNvSpPr/>
           <p:nvPr/>
         </p:nvSpPr>
@@ -21906,7 +20758,7 @@
       </p:sp>
       <p:sp>
         <p:nvSpPr>
-          <p:cNvPr id="17" name="Text 15"/>
+          <p:cNvPr id="16" name="Text 14"/>
           <p:cNvSpPr/>
           <p:nvPr/>
         </p:nvSpPr>
@@ -22148,48 +21000,7 @@
       </p:sp>
       <p:sp>
         <p:nvSpPr>
-          <p:cNvPr id="7" name="Text 5"/>
-          <p:cNvSpPr/>
-          <p:nvPr/>
-        </p:nvSpPr>
-        <p:spPr>
-          <a:xfrm>
-            <a:off x="612648" y="822960"/>
-            <a:ext cx="7498080" cy="228600"/>
-          </a:xfrm>
-          <a:prstGeom prst="rect">
-            <a:avLst/>
-          </a:prstGeom>
-          <a:noFill/>
-          <a:ln/>
-        </p:spPr>
-        <p:txBody>
-          <a:bodyPr wrap="square" lIns="0" tIns="0" rIns="0" bIns="0" rtlCol="0" anchor="ctr">
-            <a:normAutofit/>
-          </a:bodyPr>
-          <a:lstStyle/>
-          <a:p>
-            <a:pPr indent="0" marL="0">
-              <a:buNone/>
-            </a:pPr>
-            <a:r>
-              <a:rPr lang="en-US" sz="1150" dirty="0">
-                <a:solidFill>
-                  <a:srgbClr val="606B78"/>
-                </a:solidFill>
-                <a:latin typeface="Malgun Gothic" pitchFamily="34" charset="0"/>
-                <a:ea typeface="Malgun Gothic" pitchFamily="34" charset="-122"/>
-                <a:cs typeface="Malgun Gothic" pitchFamily="34" charset="-120"/>
-              </a:rPr>
-              <a:t>Command가 강력해지는 지점 체험하기</a:t>
-            </a:r>
-            <a:endParaRPr lang="en-US" sz="1150" dirty="0"/>
-          </a:p>
-        </p:txBody>
-      </p:sp>
-      <p:sp>
-        <p:nvSpPr>
-          <p:cNvPr id="8" name="Shape 6"/>
+          <p:cNvPr id="7" name="Shape 5"/>
           <p:cNvSpPr/>
           <p:nvPr/>
         </p:nvSpPr>
@@ -22216,7 +21027,7 @@
       </p:sp>
       <p:sp>
         <p:nvSpPr>
-          <p:cNvPr id="9" name="Text 7"/>
+          <p:cNvPr id="8" name="Text 6"/>
           <p:cNvSpPr/>
           <p:nvPr/>
         </p:nvSpPr>
@@ -22252,7 +21063,7 @@
       </p:sp>
       <p:sp>
         <p:nvSpPr>
-          <p:cNvPr id="10" name="Shape 8"/>
+          <p:cNvPr id="9" name="Shape 7"/>
           <p:cNvSpPr/>
           <p:nvPr/>
         </p:nvSpPr>
@@ -22277,7 +21088,7 @@
       </p:sp>
       <p:sp>
         <p:nvSpPr>
-          <p:cNvPr id="11" name="Text 9"/>
+          <p:cNvPr id="10" name="Text 8"/>
           <p:cNvSpPr/>
           <p:nvPr/>
         </p:nvSpPr>
@@ -22318,7 +21129,7 @@
       </p:sp>
       <p:sp>
         <p:nvSpPr>
-          <p:cNvPr id="12" name="Shape 10"/>
+          <p:cNvPr id="11" name="Shape 9"/>
           <p:cNvSpPr/>
           <p:nvPr/>
         </p:nvSpPr>
@@ -22343,7 +21154,7 @@
       </p:sp>
       <p:sp>
         <p:nvSpPr>
-          <p:cNvPr id="13" name="Text 11"/>
+          <p:cNvPr id="12" name="Text 10"/>
           <p:cNvSpPr/>
           <p:nvPr/>
         </p:nvSpPr>
@@ -22384,7 +21195,7 @@
       </p:sp>
       <p:sp>
         <p:nvSpPr>
-          <p:cNvPr id="14" name="Shape 12"/>
+          <p:cNvPr id="13" name="Shape 11"/>
           <p:cNvSpPr/>
           <p:nvPr/>
         </p:nvSpPr>
@@ -22409,7 +21220,7 @@
       </p:sp>
       <p:sp>
         <p:nvSpPr>
-          <p:cNvPr id="15" name="Text 13"/>
+          <p:cNvPr id="14" name="Text 12"/>
           <p:cNvSpPr/>
           <p:nvPr/>
         </p:nvSpPr>
@@ -22450,7 +21261,7 @@
       </p:sp>
       <p:sp>
         <p:nvSpPr>
-          <p:cNvPr id="16" name="Shape 14"/>
+          <p:cNvPr id="15" name="Shape 13"/>
           <p:cNvSpPr/>
           <p:nvPr/>
         </p:nvSpPr>
@@ -22475,7 +21286,7 @@
       </p:sp>
       <p:sp>
         <p:nvSpPr>
-          <p:cNvPr id="17" name="Text 15"/>
+          <p:cNvPr id="16" name="Text 14"/>
           <p:cNvSpPr/>
           <p:nvPr/>
         </p:nvSpPr>
@@ -22717,48 +21528,7 @@
       </p:sp>
       <p:sp>
         <p:nvSpPr>
-          <p:cNvPr id="7" name="Text 5"/>
-          <p:cNvSpPr/>
-          <p:nvPr/>
-        </p:nvSpPr>
-        <p:spPr>
-          <a:xfrm>
-            <a:off x="612648" y="822960"/>
-            <a:ext cx="7498080" cy="228600"/>
-          </a:xfrm>
-          <a:prstGeom prst="rect">
-            <a:avLst/>
-          </a:prstGeom>
-          <a:noFill/>
-          <a:ln/>
-        </p:spPr>
-        <p:txBody>
-          <a:bodyPr wrap="square" lIns="0" tIns="0" rIns="0" bIns="0" rtlCol="0" anchor="ctr">
-            <a:normAutofit/>
-          </a:bodyPr>
-          <a:lstStyle/>
-          <a:p>
-            <a:pPr indent="0" marL="0">
-              <a:buNone/>
-            </a:pPr>
-            <a:r>
-              <a:rPr lang="en-US" sz="1150" dirty="0">
-                <a:solidFill>
-                  <a:srgbClr val="606B78"/>
-                </a:solidFill>
-                <a:latin typeface="Malgun Gothic" pitchFamily="34" charset="0"/>
-                <a:ea typeface="Malgun Gothic" pitchFamily="34" charset="-122"/>
-                <a:cs typeface="Malgun Gothic" pitchFamily="34" charset="-120"/>
-              </a:rPr>
-              <a:t>클래스 구현과 관련 패턴까지 연결한다</a:t>
-            </a:r>
-            <a:endParaRPr lang="en-US" sz="1150" dirty="0"/>
-          </a:p>
-        </p:txBody>
-      </p:sp>
-      <p:sp>
-        <p:nvSpPr>
-          <p:cNvPr id="8" name="Shape 6"/>
+          <p:cNvPr id="7" name="Shape 5"/>
           <p:cNvSpPr/>
           <p:nvPr/>
         </p:nvSpPr>
@@ -22783,7 +21553,7 @@
       </p:sp>
       <p:sp>
         <p:nvSpPr>
-          <p:cNvPr id="9" name="Text 7"/>
+          <p:cNvPr id="8" name="Text 6"/>
           <p:cNvSpPr/>
           <p:nvPr/>
         </p:nvSpPr>
@@ -22824,7 +21594,7 @@
       </p:sp>
       <p:sp>
         <p:nvSpPr>
-          <p:cNvPr id="10" name="Shape 8"/>
+          <p:cNvPr id="9" name="Shape 7"/>
           <p:cNvSpPr/>
           <p:nvPr/>
         </p:nvSpPr>
@@ -22849,7 +21619,7 @@
       </p:sp>
       <p:sp>
         <p:nvSpPr>
-          <p:cNvPr id="11" name="Text 9"/>
+          <p:cNvPr id="10" name="Text 8"/>
           <p:cNvSpPr/>
           <p:nvPr/>
         </p:nvSpPr>
@@ -22890,7 +21660,7 @@
       </p:sp>
       <p:sp>
         <p:nvSpPr>
-          <p:cNvPr id="12" name="Shape 10"/>
+          <p:cNvPr id="11" name="Shape 9"/>
           <p:cNvSpPr/>
           <p:nvPr/>
         </p:nvSpPr>
@@ -22915,7 +21685,7 @@
       </p:sp>
       <p:sp>
         <p:nvSpPr>
-          <p:cNvPr id="13" name="Text 11"/>
+          <p:cNvPr id="12" name="Text 10"/>
           <p:cNvSpPr/>
           <p:nvPr/>
         </p:nvSpPr>
@@ -22956,7 +21726,7 @@
       </p:sp>
       <p:sp>
         <p:nvSpPr>
-          <p:cNvPr id="14" name="Shape 12"/>
+          <p:cNvPr id="13" name="Shape 11"/>
           <p:cNvSpPr/>
           <p:nvPr/>
         </p:nvSpPr>
@@ -22981,7 +21751,7 @@
       </p:sp>
       <p:sp>
         <p:nvSpPr>
-          <p:cNvPr id="15" name="Text 13"/>
+          <p:cNvPr id="14" name="Text 12"/>
           <p:cNvSpPr/>
           <p:nvPr/>
         </p:nvSpPr>
@@ -23669,17 +22439,17 @@
         </p:nvSpPr>
         <p:spPr>
           <a:xfrm>
-            <a:off x="612648" y="822960"/>
-            <a:ext cx="7498080" cy="228600"/>
-          </a:xfrm>
-          <a:prstGeom prst="rect">
-            <a:avLst/>
-          </a:prstGeom>
-          <a:noFill/>
-          <a:ln/>
-        </p:spPr>
-        <p:txBody>
-          <a:bodyPr wrap="square" lIns="0" tIns="0" rIns="0" bIns="0" rtlCol="0" anchor="ctr">
+            <a:off x="713232" y="1115568"/>
+            <a:ext cx="7498080" cy="274320"/>
+          </a:xfrm>
+          <a:prstGeom prst="rect">
+            <a:avLst/>
+          </a:prstGeom>
+          <a:noFill/>
+          <a:ln/>
+        </p:spPr>
+        <p:txBody>
+          <a:bodyPr wrap="square" lIns="254" tIns="254" rIns="254" bIns="254" rtlCol="0" anchor="t">
             <a:normAutofit/>
           </a:bodyPr>
           <a:lstStyle/>
@@ -23688,55 +22458,14 @@
               <a:buNone/>
             </a:pPr>
             <a:r>
-              <a:rPr lang="en-US" sz="1150" dirty="0">
-                <a:solidFill>
-                  <a:srgbClr val="606B78"/>
+              <a:rPr lang="en-US" sz="1550" b="1" dirty="0">
+                <a:solidFill>
+                  <a:srgbClr val="0F766E"/>
                 </a:solidFill>
                 <a:latin typeface="Malgun Gothic" pitchFamily="34" charset="0"/>
                 <a:ea typeface="Malgun Gothic" pitchFamily="34" charset="-122"/>
                 <a:cs typeface="Malgun Gothic" pitchFamily="34" charset="-120"/>
               </a:rPr>
-              <a:t>처음에는 쉽지만 확장할수록 굳어진다</a:t>
-            </a:r>
-            <a:endParaRPr lang="en-US" sz="1150" dirty="0"/>
-          </a:p>
-        </p:txBody>
-      </p:sp>
-      <p:sp>
-        <p:nvSpPr>
-          <p:cNvPr id="8" name="Text 6"/>
-          <p:cNvSpPr/>
-          <p:nvPr/>
-        </p:nvSpPr>
-        <p:spPr>
-          <a:xfrm>
-            <a:off x="713232" y="1115568"/>
-            <a:ext cx="7498080" cy="274320"/>
-          </a:xfrm>
-          <a:prstGeom prst="rect">
-            <a:avLst/>
-          </a:prstGeom>
-          <a:noFill/>
-          <a:ln/>
-        </p:spPr>
-        <p:txBody>
-          <a:bodyPr wrap="square" lIns="254" tIns="254" rIns="254" bIns="254" rtlCol="0" anchor="t">
-            <a:normAutofit/>
-          </a:bodyPr>
-          <a:lstStyle/>
-          <a:p>
-            <a:pPr indent="0" marL="0">
-              <a:buNone/>
-            </a:pPr>
-            <a:r>
-              <a:rPr lang="en-US" sz="1550" b="1" dirty="0">
-                <a:solidFill>
-                  <a:srgbClr val="0F766E"/>
-                </a:solidFill>
-                <a:latin typeface="Malgun Gothic" pitchFamily="34" charset="0"/>
-                <a:ea typeface="Malgun Gothic" pitchFamily="34" charset="-122"/>
-                <a:cs typeface="Malgun Gothic" pitchFamily="34" charset="-120"/>
-              </a:rPr>
               <a:t>버튼과 행동이 코드 안에서 고정되어 있다.</a:t>
             </a:r>
             <a:endParaRPr lang="en-US" sz="1550" dirty="0"/>
@@ -23745,7 +22474,7 @@
       </p:sp>
       <p:sp>
         <p:nvSpPr>
-          <p:cNvPr id="9" name="Shape 7"/>
+          <p:cNvPr id="8" name="Shape 6"/>
           <p:cNvSpPr/>
           <p:nvPr/>
         </p:nvSpPr>
@@ -23774,7 +22503,7 @@
       </p:sp>
       <p:sp>
         <p:nvSpPr>
-          <p:cNvPr id="10" name="Text 8"/>
+          <p:cNvPr id="9" name="Text 7"/>
           <p:cNvSpPr/>
           <p:nvPr/>
         </p:nvSpPr>
@@ -25004,17 +23733,17 @@
         </p:nvSpPr>
         <p:spPr>
           <a:xfrm>
-            <a:off x="612648" y="822960"/>
-            <a:ext cx="7498080" cy="228600"/>
-          </a:xfrm>
-          <a:prstGeom prst="rect">
-            <a:avLst/>
-          </a:prstGeom>
-          <a:noFill/>
-          <a:ln/>
-        </p:spPr>
-        <p:txBody>
-          <a:bodyPr wrap="square" lIns="0" tIns="0" rIns="0" bIns="0" rtlCol="0" anchor="ctr">
+            <a:off x="713232" y="1115568"/>
+            <a:ext cx="7498080" cy="274320"/>
+          </a:xfrm>
+          <a:prstGeom prst="rect">
+            <a:avLst/>
+          </a:prstGeom>
+          <a:noFill/>
+          <a:ln/>
+        </p:spPr>
+        <p:txBody>
+          <a:bodyPr wrap="square" lIns="254" tIns="254" rIns="254" bIns="254" rtlCol="0" anchor="t">
             <a:normAutofit/>
           </a:bodyPr>
           <a:lstStyle/>
@@ -25023,55 +23752,14 @@
               <a:buNone/>
             </a:pPr>
             <a:r>
-              <a:rPr lang="en-US" sz="1150" dirty="0">
-                <a:solidFill>
-                  <a:srgbClr val="606B78"/>
+              <a:rPr lang="en-US" sz="1550" b="1" dirty="0">
+                <a:solidFill>
+                  <a:srgbClr val="0F766E"/>
                 </a:solidFill>
                 <a:latin typeface="Malgun Gothic" pitchFamily="34" charset="0"/>
                 <a:ea typeface="Malgun Gothic" pitchFamily="34" charset="-122"/>
                 <a:cs typeface="Malgun Gothic" pitchFamily="34" charset="-120"/>
               </a:rPr>
-              <a:t>처음에는 인터페이스 하나면 충분하다</a:t>
-            </a:r>
-            <a:endParaRPr lang="en-US" sz="1150" dirty="0"/>
-          </a:p>
-        </p:txBody>
-      </p:sp>
-      <p:sp>
-        <p:nvSpPr>
-          <p:cNvPr id="8" name="Text 6"/>
-          <p:cNvSpPr/>
-          <p:nvPr/>
-        </p:nvSpPr>
-        <p:spPr>
-          <a:xfrm>
-            <a:off x="713232" y="1115568"/>
-            <a:ext cx="7498080" cy="274320"/>
-          </a:xfrm>
-          <a:prstGeom prst="rect">
-            <a:avLst/>
-          </a:prstGeom>
-          <a:noFill/>
-          <a:ln/>
-        </p:spPr>
-        <p:txBody>
-          <a:bodyPr wrap="square" lIns="254" tIns="254" rIns="254" bIns="254" rtlCol="0" anchor="t">
-            <a:normAutofit/>
-          </a:bodyPr>
-          <a:lstStyle/>
-          <a:p>
-            <a:pPr indent="0" marL="0">
-              <a:buNone/>
-            </a:pPr>
-            <a:r>
-              <a:rPr lang="en-US" sz="1550" b="1" dirty="0">
-                <a:solidFill>
-                  <a:srgbClr val="0F766E"/>
-                </a:solidFill>
-                <a:latin typeface="Malgun Gothic" pitchFamily="34" charset="0"/>
-                <a:ea typeface="Malgun Gothic" pitchFamily="34" charset="-122"/>
-                <a:cs typeface="Malgun Gothic" pitchFamily="34" charset="-120"/>
-              </a:rPr>
               <a:t>Command는 보통 Execute 하나로 시작한다.</a:t>
             </a:r>
             <a:endParaRPr lang="en-US" sz="1550" dirty="0"/>
@@ -25080,7 +23768,7 @@
       </p:sp>
       <p:sp>
         <p:nvSpPr>
-          <p:cNvPr id="9" name="Shape 7"/>
+          <p:cNvPr id="8" name="Shape 6"/>
           <p:cNvSpPr/>
           <p:nvPr/>
         </p:nvSpPr>
@@ -25109,7 +23797,7 @@
       </p:sp>
       <p:sp>
         <p:nvSpPr>
-          <p:cNvPr id="10" name="Text 8"/>
+          <p:cNvPr id="9" name="Text 7"/>
           <p:cNvSpPr/>
           <p:nvPr/>
         </p:nvSpPr>
@@ -25533,17 +24221,17 @@
         </p:nvSpPr>
         <p:spPr>
           <a:xfrm>
-            <a:off x="612648" y="822960"/>
-            <a:ext cx="7498080" cy="228600"/>
-          </a:xfrm>
-          <a:prstGeom prst="rect">
-            <a:avLst/>
-          </a:prstGeom>
-          <a:noFill/>
-          <a:ln/>
-        </p:spPr>
-        <p:txBody>
-          <a:bodyPr wrap="square" lIns="0" tIns="0" rIns="0" bIns="0" rtlCol="0" anchor="ctr">
+            <a:off x="713232" y="1115568"/>
+            <a:ext cx="7498080" cy="274320"/>
+          </a:xfrm>
+          <a:prstGeom prst="rect">
+            <a:avLst/>
+          </a:prstGeom>
+          <a:noFill/>
+          <a:ln/>
+        </p:spPr>
+        <p:txBody>
+          <a:bodyPr wrap="square" lIns="254" tIns="254" rIns="254" bIns="254" rtlCol="0" anchor="t">
             <a:normAutofit/>
           </a:bodyPr>
           <a:lstStyle/>
@@ -25552,55 +24240,14 @@
               <a:buNone/>
             </a:pPr>
             <a:r>
-              <a:rPr lang="en-US" sz="1150" dirty="0">
-                <a:solidFill>
-                  <a:srgbClr val="606B78"/>
+              <a:rPr lang="en-US" sz="1550" b="1" dirty="0">
+                <a:solidFill>
+                  <a:srgbClr val="0F766E"/>
                 </a:solidFill>
                 <a:latin typeface="Malgun Gothic" pitchFamily="34" charset="0"/>
                 <a:ea typeface="Malgun Gothic" pitchFamily="34" charset="-122"/>
                 <a:cs typeface="Malgun Gothic" pitchFamily="34" charset="-120"/>
               </a:rPr>
-              <a:t>버튼 매핑은 객체 교체 문제가 된다</a:t>
-            </a:r>
-            <a:endParaRPr lang="en-US" sz="1150" dirty="0"/>
-          </a:p>
-        </p:txBody>
-      </p:sp>
-      <p:sp>
-        <p:nvSpPr>
-          <p:cNvPr id="8" name="Text 6"/>
-          <p:cNvSpPr/>
-          <p:nvPr/>
-        </p:nvSpPr>
-        <p:spPr>
-          <a:xfrm>
-            <a:off x="713232" y="1115568"/>
-            <a:ext cx="7498080" cy="274320"/>
-          </a:xfrm>
-          <a:prstGeom prst="rect">
-            <a:avLst/>
-          </a:prstGeom>
-          <a:noFill/>
-          <a:ln/>
-        </p:spPr>
-        <p:txBody>
-          <a:bodyPr wrap="square" lIns="254" tIns="254" rIns="254" bIns="254" rtlCol="0" anchor="t">
-            <a:normAutofit/>
-          </a:bodyPr>
-          <a:lstStyle/>
-          <a:p>
-            <a:pPr indent="0" marL="0">
-              <a:buNone/>
-            </a:pPr>
-            <a:r>
-              <a:rPr lang="en-US" sz="1550" b="1" dirty="0">
-                <a:solidFill>
-                  <a:srgbClr val="0F766E"/>
-                </a:solidFill>
-                <a:latin typeface="Malgun Gothic" pitchFamily="34" charset="0"/>
-                <a:ea typeface="Malgun Gothic" pitchFamily="34" charset="-122"/>
-                <a:cs typeface="Malgun Gothic" pitchFamily="34" charset="-120"/>
-              </a:rPr>
               <a:t>입력 코드는 구체 행동을 모른다.</a:t>
             </a:r>
             <a:endParaRPr lang="en-US" sz="1550" dirty="0"/>
@@ -25609,7 +24256,7 @@
       </p:sp>
       <p:sp>
         <p:nvSpPr>
-          <p:cNvPr id="9" name="Shape 7"/>
+          <p:cNvPr id="8" name="Shape 6"/>
           <p:cNvSpPr/>
           <p:nvPr/>
         </p:nvSpPr>
@@ -25638,7 +24285,7 @@
       </p:sp>
       <p:sp>
         <p:nvSpPr>
-          <p:cNvPr id="10" name="Text 8"/>
+          <p:cNvPr id="9" name="Text 7"/>
           <p:cNvSpPr/>
           <p:nvPr/>
         </p:nvSpPr>

</xml_diff>

<commit_message>
Fix text spacing and overlap in Command Pattern PPT
</commit_message>
<xml_diff>
--- a/강의자료/유니티 프로그래밍 패턴 2차시 - Command Pattern.pptx
+++ b/강의자료/유니티 프로그래밍 패턴 2차시 - Command Pattern.pptx
@@ -6340,7 +6340,7 @@
         </p:nvSpPr>
         <p:spPr>
           <a:xfrm>
-            <a:off x="859536" y="2020824"/>
+            <a:off x="859536" y="1947672"/>
             <a:ext cx="82296" cy="82296"/>
           </a:xfrm>
           <a:prstGeom prst="ellipse">
@@ -6365,8 +6365,8 @@
         </p:nvSpPr>
         <p:spPr>
           <a:xfrm>
-            <a:off x="1060704" y="1920240"/>
-            <a:ext cx="3246120" cy="475488"/>
+            <a:off x="1060704" y="1847088"/>
+            <a:ext cx="3246120" cy="621792"/>
           </a:xfrm>
           <a:prstGeom prst="rect">
             <a:avLst/>
@@ -6384,7 +6384,7 @@
               <a:buNone/>
             </a:pPr>
             <a:r>
-              <a:rPr lang="en-US" sz="1630" dirty="0">
+              <a:rPr lang="en-US" sz="1420" dirty="0">
                 <a:solidFill>
                   <a:srgbClr val="17212B"/>
                 </a:solidFill>
@@ -6394,7 +6394,7 @@
               </a:rPr>
               <a:t>JumpCommand가 PlayerActions.Jump()를 직접 호출한다.</a:t>
             </a:r>
-            <a:endParaRPr lang="en-US" sz="1630" dirty="0"/>
+            <a:endParaRPr lang="en-US" sz="1420" dirty="0"/>
           </a:p>
         </p:txBody>
       </p:sp>
@@ -6406,7 +6406,7 @@
         </p:nvSpPr>
         <p:spPr>
           <a:xfrm>
-            <a:off x="859536" y="2670048"/>
+            <a:off x="859536" y="2734056"/>
             <a:ext cx="82296" cy="82296"/>
           </a:xfrm>
           <a:prstGeom prst="ellipse">
@@ -6431,8 +6431,8 @@
         </p:nvSpPr>
         <p:spPr>
           <a:xfrm>
-            <a:off x="1060704" y="2569464"/>
-            <a:ext cx="3246120" cy="475488"/>
+            <a:off x="1060704" y="2633472"/>
+            <a:ext cx="3246120" cy="621792"/>
           </a:xfrm>
           <a:prstGeom prst="rect">
             <a:avLst/>
@@ -6450,7 +6450,7 @@
               <a:buNone/>
             </a:pPr>
             <a:r>
-              <a:rPr lang="en-US" sz="1630" dirty="0">
+              <a:rPr lang="en-US" sz="1420" dirty="0">
                 <a:solidFill>
                   <a:srgbClr val="17212B"/>
                 </a:solidFill>
@@ -6460,7 +6460,7 @@
               </a:rPr>
               <a:t>AI 캐릭터나 다른 유닛에게 재사용하기 어렵다.</a:t>
             </a:r>
-            <a:endParaRPr lang="en-US" sz="1630" dirty="0"/>
+            <a:endParaRPr lang="en-US" sz="1420" dirty="0"/>
           </a:p>
         </p:txBody>
       </p:sp>
@@ -6472,7 +6472,7 @@
         </p:nvSpPr>
         <p:spPr>
           <a:xfrm>
-            <a:off x="859536" y="3319272"/>
+            <a:off x="859536" y="3520440"/>
             <a:ext cx="82296" cy="82296"/>
           </a:xfrm>
           <a:prstGeom prst="ellipse">
@@ -6497,8 +6497,8 @@
         </p:nvSpPr>
         <p:spPr>
           <a:xfrm>
-            <a:off x="1060704" y="3218688"/>
-            <a:ext cx="3246120" cy="475488"/>
+            <a:off x="1060704" y="3419856"/>
+            <a:ext cx="3246120" cy="621792"/>
           </a:xfrm>
           <a:prstGeom prst="rect">
             <a:avLst/>
@@ -6516,7 +6516,7 @@
               <a:buNone/>
             </a:pPr>
             <a:r>
-              <a:rPr lang="en-US" sz="1630" dirty="0">
+              <a:rPr lang="en-US" sz="1420" dirty="0">
                 <a:solidFill>
                   <a:srgbClr val="17212B"/>
                 </a:solidFill>
@@ -6526,7 +6526,7 @@
               </a:rPr>
               <a:t>명령이 실행 대상까지 알고 있다.</a:t>
             </a:r>
-            <a:endParaRPr lang="en-US" sz="1630" dirty="0"/>
+            <a:endParaRPr lang="en-US" sz="1420" dirty="0"/>
           </a:p>
         </p:txBody>
       </p:sp>
@@ -6579,7 +6579,7 @@
         </p:nvSpPr>
         <p:spPr>
           <a:xfrm>
-            <a:off x="4855464" y="2020824"/>
+            <a:off x="4855464" y="1947672"/>
             <a:ext cx="82296" cy="82296"/>
           </a:xfrm>
           <a:prstGeom prst="ellipse">
@@ -6604,8 +6604,8 @@
         </p:nvSpPr>
         <p:spPr>
           <a:xfrm>
-            <a:off x="5056632" y="1920240"/>
-            <a:ext cx="3246120" cy="475488"/>
+            <a:off x="5056632" y="1847088"/>
+            <a:ext cx="3246120" cy="621792"/>
           </a:xfrm>
           <a:prstGeom prst="rect">
             <a:avLst/>
@@ -6623,7 +6623,7 @@
               <a:buNone/>
             </a:pPr>
             <a:r>
-              <a:rPr lang="en-US" sz="1630" dirty="0">
+              <a:rPr lang="en-US" sz="1420" dirty="0">
                 <a:solidFill>
                   <a:srgbClr val="17212B"/>
                 </a:solidFill>
@@ -6633,7 +6633,7 @@
               </a:rPr>
               <a:t>Command는 행동만 알고 대상은 밖에서 받는다.</a:t>
             </a:r>
-            <a:endParaRPr lang="en-US" sz="1630" dirty="0"/>
+            <a:endParaRPr lang="en-US" sz="1420" dirty="0"/>
           </a:p>
         </p:txBody>
       </p:sp>
@@ -6645,7 +6645,7 @@
         </p:nvSpPr>
         <p:spPr>
           <a:xfrm>
-            <a:off x="4855464" y="2670048"/>
+            <a:off x="4855464" y="2734056"/>
             <a:ext cx="82296" cy="82296"/>
           </a:xfrm>
           <a:prstGeom prst="ellipse">
@@ -6670,8 +6670,8 @@
         </p:nvSpPr>
         <p:spPr>
           <a:xfrm>
-            <a:off x="5056632" y="2569464"/>
-            <a:ext cx="3246120" cy="475488"/>
+            <a:off x="5056632" y="2633472"/>
+            <a:ext cx="3246120" cy="621792"/>
           </a:xfrm>
           <a:prstGeom prst="rect">
             <a:avLst/>
@@ -6689,7 +6689,7 @@
               <a:buNone/>
             </a:pPr>
             <a:r>
-              <a:rPr lang="en-US" sz="1630" dirty="0">
+              <a:rPr lang="en-US" sz="1420" dirty="0">
                 <a:solidFill>
                   <a:srgbClr val="17212B"/>
                 </a:solidFill>
@@ -6699,7 +6699,7 @@
               </a:rPr>
               <a:t>Execute(actor) 형태로 실행 대상을 분리한다.</a:t>
             </a:r>
-            <a:endParaRPr lang="en-US" sz="1630" dirty="0"/>
+            <a:endParaRPr lang="en-US" sz="1420" dirty="0"/>
           </a:p>
         </p:txBody>
       </p:sp>
@@ -6711,7 +6711,7 @@
         </p:nvSpPr>
         <p:spPr>
           <a:xfrm>
-            <a:off x="4855464" y="3319272"/>
+            <a:off x="4855464" y="3520440"/>
             <a:ext cx="82296" cy="82296"/>
           </a:xfrm>
           <a:prstGeom prst="ellipse">
@@ -6736,8 +6736,8 @@
         </p:nvSpPr>
         <p:spPr>
           <a:xfrm>
-            <a:off x="5056632" y="3218688"/>
-            <a:ext cx="3246120" cy="475488"/>
+            <a:off x="5056632" y="3419856"/>
+            <a:ext cx="3246120" cy="621792"/>
           </a:xfrm>
           <a:prstGeom prst="rect">
             <a:avLst/>
@@ -6755,7 +6755,7 @@
               <a:buNone/>
             </a:pPr>
             <a:r>
-              <a:rPr lang="en-US" sz="1630" dirty="0">
+              <a:rPr lang="en-US" sz="1420" dirty="0">
                 <a:solidFill>
                   <a:srgbClr val="17212B"/>
                 </a:solidFill>
@@ -6765,7 +6765,7 @@
               </a:rPr>
               <a:t>같은 명령을 여러 Actor에게 적용한다.</a:t>
             </a:r>
-            <a:endParaRPr lang="en-US" sz="1630" dirty="0"/>
+            <a:endParaRPr lang="en-US" sz="1420" dirty="0"/>
           </a:p>
         </p:txBody>
       </p:sp>
@@ -15844,7 +15844,7 @@
         <p:spPr>
           <a:xfrm>
             <a:off x="1005840" y="1353312"/>
-            <a:ext cx="7406640" cy="420624"/>
+            <a:ext cx="7406640" cy="512064"/>
           </a:xfrm>
           <a:prstGeom prst="rect">
             <a:avLst/>
@@ -15862,7 +15862,7 @@
               <a:buNone/>
             </a:pPr>
             <a:r>
-              <a:rPr lang="en-US" sz="1770" dirty="0">
+              <a:rPr lang="en-US" sz="1660" dirty="0">
                 <a:solidFill>
                   <a:srgbClr val="17212B"/>
                 </a:solidFill>
@@ -15872,7 +15872,7 @@
               </a:rPr>
               <a:t>Configuring Input: 버튼과 행동을 직접 연결하지 않는다.</a:t>
             </a:r>
-            <a:endParaRPr lang="en-US" sz="1770" dirty="0"/>
+            <a:endParaRPr lang="en-US" sz="1660" dirty="0"/>
           </a:p>
         </p:txBody>
       </p:sp>
@@ -15884,7 +15884,7 @@
         </p:nvSpPr>
         <p:spPr>
           <a:xfrm>
-            <a:off x="804672" y="2103120"/>
+            <a:off x="804672" y="2176272"/>
             <a:ext cx="82296" cy="82296"/>
           </a:xfrm>
           <a:prstGeom prst="ellipse">
@@ -15909,8 +15909,8 @@
         </p:nvSpPr>
         <p:spPr>
           <a:xfrm>
-            <a:off x="1005840" y="2002536"/>
-            <a:ext cx="7406640" cy="420624"/>
+            <a:off x="1005840" y="2075688"/>
+            <a:ext cx="7406640" cy="512064"/>
           </a:xfrm>
           <a:prstGeom prst="rect">
             <a:avLst/>
@@ -15928,7 +15928,7 @@
               <a:buNone/>
             </a:pPr>
             <a:r>
-              <a:rPr lang="en-US" sz="1770" dirty="0">
+              <a:rPr lang="en-US" sz="1660" dirty="0">
                 <a:solidFill>
                   <a:srgbClr val="17212B"/>
                 </a:solidFill>
@@ -15938,7 +15938,7 @@
               </a:rPr>
               <a:t>Directions for Actors: 명령은 특정 플레이어가 아니라 Actor에게 실행된다.</a:t>
             </a:r>
-            <a:endParaRPr lang="en-US" sz="1770" dirty="0"/>
+            <a:endParaRPr lang="en-US" sz="1660" dirty="0"/>
           </a:p>
         </p:txBody>
       </p:sp>
@@ -15950,7 +15950,7 @@
         </p:nvSpPr>
         <p:spPr>
           <a:xfrm>
-            <a:off x="804672" y="2752344"/>
+            <a:off x="804672" y="2898648"/>
             <a:ext cx="82296" cy="82296"/>
           </a:xfrm>
           <a:prstGeom prst="ellipse">
@@ -15975,8 +15975,8 @@
         </p:nvSpPr>
         <p:spPr>
           <a:xfrm>
-            <a:off x="1005840" y="2651760"/>
-            <a:ext cx="7406640" cy="420624"/>
+            <a:off x="1005840" y="2798064"/>
+            <a:ext cx="7406640" cy="512064"/>
           </a:xfrm>
           <a:prstGeom prst="rect">
             <a:avLst/>
@@ -15994,7 +15994,7 @@
               <a:buNone/>
             </a:pPr>
             <a:r>
-              <a:rPr lang="en-US" sz="1770" dirty="0">
+              <a:rPr lang="en-US" sz="1660" dirty="0">
                 <a:solidFill>
                   <a:srgbClr val="17212B"/>
                 </a:solidFill>
@@ -16004,7 +16004,7 @@
               </a:rPr>
               <a:t>Command Stream: 큐, 네트워크, 리플레이로 확장된다.</a:t>
             </a:r>
-            <a:endParaRPr lang="en-US" sz="1770" dirty="0"/>
+            <a:endParaRPr lang="en-US" sz="1660" dirty="0"/>
           </a:p>
         </p:txBody>
       </p:sp>
@@ -16016,7 +16016,7 @@
         </p:nvSpPr>
         <p:spPr>
           <a:xfrm>
-            <a:off x="804672" y="3401568"/>
+            <a:off x="804672" y="3621024"/>
             <a:ext cx="82296" cy="82296"/>
           </a:xfrm>
           <a:prstGeom prst="ellipse">
@@ -16041,8 +16041,8 @@
         </p:nvSpPr>
         <p:spPr>
           <a:xfrm>
-            <a:off x="1005840" y="3300984"/>
-            <a:ext cx="7406640" cy="420624"/>
+            <a:off x="1005840" y="3520440"/>
+            <a:ext cx="7406640" cy="512064"/>
           </a:xfrm>
           <a:prstGeom prst="rect">
             <a:avLst/>
@@ -16060,7 +16060,7 @@
               <a:buNone/>
             </a:pPr>
             <a:r>
-              <a:rPr lang="en-US" sz="1770" dirty="0">
+              <a:rPr lang="en-US" sz="1660" dirty="0">
                 <a:solidFill>
                   <a:srgbClr val="17212B"/>
                 </a:solidFill>
@@ -16070,7 +16070,7 @@
               </a:rPr>
               <a:t>Undo and Redo: 실행한 명령이 되돌릴 방법을 안다.</a:t>
             </a:r>
-            <a:endParaRPr lang="en-US" sz="1770" dirty="0"/>
+            <a:endParaRPr lang="en-US" sz="1660" dirty="0"/>
           </a:p>
         </p:txBody>
       </p:sp>
@@ -21560,7 +21560,7 @@
         <p:spPr>
           <a:xfrm>
             <a:off x="1005840" y="1353312"/>
-            <a:ext cx="7406640" cy="420624"/>
+            <a:ext cx="7406640" cy="512064"/>
           </a:xfrm>
           <a:prstGeom prst="rect">
             <a:avLst/>
@@ -21578,7 +21578,7 @@
               <a:buNone/>
             </a:pPr>
             <a:r>
-              <a:rPr lang="en-US" sz="1770" dirty="0">
+              <a:rPr lang="en-US" sz="1660" dirty="0">
                 <a:solidFill>
                   <a:srgbClr val="17212B"/>
                 </a:solidFill>
@@ -21588,7 +21588,7 @@
               </a:rPr>
               <a:t>Classy and Dysfunctional: 클래스 대신 함수/클로저로도 표현할 수 있다.</a:t>
             </a:r>
-            <a:endParaRPr lang="en-US" sz="1770" dirty="0"/>
+            <a:endParaRPr lang="en-US" sz="1660" dirty="0"/>
           </a:p>
         </p:txBody>
       </p:sp>
@@ -21600,7 +21600,7 @@
         </p:nvSpPr>
         <p:spPr>
           <a:xfrm>
-            <a:off x="804672" y="2103120"/>
+            <a:off x="804672" y="2176272"/>
             <a:ext cx="82296" cy="82296"/>
           </a:xfrm>
           <a:prstGeom prst="ellipse">
@@ -21625,8 +21625,8 @@
         </p:nvSpPr>
         <p:spPr>
           <a:xfrm>
-            <a:off x="1005840" y="2002536"/>
-            <a:ext cx="7406640" cy="420624"/>
+            <a:off x="1005840" y="2075688"/>
+            <a:ext cx="7406640" cy="512064"/>
           </a:xfrm>
           <a:prstGeom prst="rect">
             <a:avLst/>
@@ -21644,7 +21644,7 @@
               <a:buNone/>
             </a:pPr>
             <a:r>
-              <a:rPr lang="en-US" sz="1770" dirty="0">
+              <a:rPr lang="en-US" sz="1660" dirty="0">
                 <a:solidFill>
                   <a:srgbClr val="17212B"/>
                 </a:solidFill>
@@ -21654,7 +21654,7 @@
               </a:rPr>
               <a:t>Subclass Sandbox: Command 클래스가 많아질 때 공통 도우미를 제공한다.</a:t>
             </a:r>
-            <a:endParaRPr lang="en-US" sz="1770" dirty="0"/>
+            <a:endParaRPr lang="en-US" sz="1660" dirty="0"/>
           </a:p>
         </p:txBody>
       </p:sp>
@@ -21666,7 +21666,7 @@
         </p:nvSpPr>
         <p:spPr>
           <a:xfrm>
-            <a:off x="804672" y="2752344"/>
+            <a:off x="804672" y="2898648"/>
             <a:ext cx="82296" cy="82296"/>
           </a:xfrm>
           <a:prstGeom prst="ellipse">
@@ -21691,8 +21691,8 @@
         </p:nvSpPr>
         <p:spPr>
           <a:xfrm>
-            <a:off x="1005840" y="2651760"/>
-            <a:ext cx="7406640" cy="420624"/>
+            <a:off x="1005840" y="2798064"/>
+            <a:ext cx="7406640" cy="512064"/>
           </a:xfrm>
           <a:prstGeom prst="rect">
             <a:avLst/>
@@ -21710,7 +21710,7 @@
               <a:buNone/>
             </a:pPr>
             <a:r>
-              <a:rPr lang="en-US" sz="1770" dirty="0">
+              <a:rPr lang="en-US" sz="1660" dirty="0">
                 <a:solidFill>
                   <a:srgbClr val="17212B"/>
                 </a:solidFill>
@@ -21720,7 +21720,7 @@
               </a:rPr>
               <a:t>Chain of Responsibility: 명령 처리자를 계층적으로 찾는다.</a:t>
             </a:r>
-            <a:endParaRPr lang="en-US" sz="1770" dirty="0"/>
+            <a:endParaRPr lang="en-US" sz="1660" dirty="0"/>
           </a:p>
         </p:txBody>
       </p:sp>
@@ -21732,7 +21732,7 @@
         </p:nvSpPr>
         <p:spPr>
           <a:xfrm>
-            <a:off x="804672" y="3401568"/>
+            <a:off x="804672" y="3621024"/>
             <a:ext cx="82296" cy="82296"/>
           </a:xfrm>
           <a:prstGeom prst="ellipse">
@@ -21757,8 +21757,8 @@
         </p:nvSpPr>
         <p:spPr>
           <a:xfrm>
-            <a:off x="1005840" y="3300984"/>
-            <a:ext cx="7406640" cy="420624"/>
+            <a:off x="1005840" y="3520440"/>
+            <a:ext cx="7406640" cy="512064"/>
           </a:xfrm>
           <a:prstGeom prst="rect">
             <a:avLst/>
@@ -21776,7 +21776,7 @@
               <a:buNone/>
             </a:pPr>
             <a:r>
-              <a:rPr lang="en-US" sz="1770" dirty="0">
+              <a:rPr lang="en-US" sz="1660" dirty="0">
                 <a:solidFill>
                   <a:srgbClr val="17212B"/>
                 </a:solidFill>
@@ -21786,7 +21786,7 @@
               </a:rPr>
               <a:t>Flyweight: 상태 없는 Command는 공유할 수 있다.</a:t>
             </a:r>
-            <a:endParaRPr lang="en-US" sz="1770" dirty="0"/>
+            <a:endParaRPr lang="en-US" sz="1660" dirty="0"/>
           </a:p>
         </p:txBody>
       </p:sp>

</xml_diff>